<commit_message>
Remove speaker notes from premium Grade 5 Sage demo PPT.
Co-authored-by: Cursor <cursoragent@cursor.com>
</commit_message>
<xml_diff>
--- a/Grade5_Sage_Premium_English_Demo_90min.pptx
+++ b/Grade5_Sage_Premium_English_Demo_90min.pptx
@@ -529,77 +529,7 @@
         <p:txBody>
           <a:bodyPr/>
           <a:lstStyle/>
-          <a:p>
-            <a:r>
-              <a:t>WHAT TO SAY:</a:t>
-            </a:r>
-          </a:p>
-          <a:p>
-            <a:r>
-              <a:t>Hi Sage! Welcome to your English adventure. We will play games, read a mystery, and level up your English superpowers.</a:t>
-            </a:r>
-          </a:p>
           <a:p/>
-          <a:p>
-            <a:r>
-              <a:t>STUDENT ACTIVITY:</a:t>
-            </a:r>
-          </a:p>
-          <a:p>
-            <a:r>
-              <a:t>Wave hello; say one word that means 'fun' to you.</a:t>
-            </a:r>
-          </a:p>
-          <a:p/>
-          <a:p>
-            <a:r>
-              <a:t>EXPECTED ANSWERS / RESPONSES:</a:t>
-            </a:r>
-          </a:p>
-          <a:p>
-            <a:r>
-              <a:t>Student greets; may say excited/nervous/happy.</a:t>
-            </a:r>
-          </a:p>
-          <a:p/>
-          <a:p>
-            <a:r>
-              <a:t>COMMON MISTAKES:</a:t>
-            </a:r>
-          </a:p>
-          <a:p>
-            <a:r>
-              <a:t>One-word answers only at first.</a:t>
-            </a:r>
-          </a:p>
-          <a:p/>
-          <a:p>
-            <a:r>
-              <a:t>ASSESSMENT TIPS:</a:t>
-            </a:r>
-          </a:p>
-          <a:p>
-            <a:r>
-              <a:t>Watch eye contact, volume, first-sentence length.</a:t>
-            </a:r>
-          </a:p>
-          <a:p/>
-          <a:p>
-            <a:r>
-              <a:t>EXTENSION QUESTIONS:</a:t>
-            </a:r>
-          </a:p>
-          <a:p>
-            <a:r>
-              <a:t>If shy: offer choices (cat/dog/sports?).</a:t>
-            </a:r>
-          </a:p>
-          <a:p/>
-          <a:p>
-            <a:r>
-              <a:t>TIMING: 5 min</a:t>
-            </a:r>
-          </a:p>
         </p:txBody>
       </p:sp>
       <p:sp>
@@ -665,77 +595,7 @@
         <p:txBody>
           <a:bodyPr/>
           <a:lstStyle/>
-          <a:p>
-            <a:r>
-              <a:t>WHAT TO SAY:</a:t>
-            </a:r>
-          </a:p>
-          <a:p>
-            <a:r>
-              <a:t>Act out time words (now/yesterday/tomorrow).</a:t>
-            </a:r>
-          </a:p>
           <a:p/>
-          <a:p>
-            <a:r>
-              <a:t>STUDENT ACTIVITY:</a:t>
-            </a:r>
-          </a:p>
-          <a:p>
-            <a:r>
-              <a:t>Repeat examples; make one new sentence each tense.</a:t>
-            </a:r>
-          </a:p>
-          <a:p/>
-          <a:p>
-            <a:r>
-              <a:t>EXPECTED ANSWERS / RESPONSES:</a:t>
-            </a:r>
-          </a:p>
-          <a:p>
-            <a:r>
-              <a:t>Correct tense markers (-s, is __ing, -ed, will).</a:t>
-            </a:r>
-          </a:p>
-          <a:p/>
-          <a:p>
-            <a:r>
-              <a:t>COMMON MISTAKES:</a:t>
-            </a:r>
-          </a:p>
-          <a:p>
-            <a:r>
-              <a:t>Mixing past and present.</a:t>
-            </a:r>
-          </a:p>
-          <a:p/>
-          <a:p>
-            <a:r>
-              <a:t>ASSESSMENT TIPS:</a:t>
-            </a:r>
-          </a:p>
-          <a:p>
-            <a:r>
-              <a:t>Tense concept understanding.</a:t>
-            </a:r>
-          </a:p>
-          <a:p/>
-          <a:p>
-            <a:r>
-              <a:t>EXTENSION QUESTIONS:</a:t>
-            </a:r>
-          </a:p>
-          <a:p>
-            <a:r>
-              <a:t>Change 'found' to future.</a:t>
-            </a:r>
-          </a:p>
-          <a:p/>
-          <a:p>
-            <a:r>
-              <a:t>TIMING: Grammar 25 min</a:t>
-            </a:r>
-          </a:p>
         </p:txBody>
       </p:sp>
       <p:sp>
@@ -801,77 +661,7 @@
         <p:txBody>
           <a:bodyPr/>
           <a:lstStyle/>
-          <a:p>
-            <a:r>
-              <a:t>WHAT TO SAY:</a:t>
-            </a:r>
-          </a:p>
-          <a:p>
-            <a:r>
-              <a:t>Think aloud for #1.</a:t>
-            </a:r>
-          </a:p>
           <a:p/>
-          <a:p>
-            <a:r>
-              <a:t>STUDENT ACTIVITY:</a:t>
-            </a:r>
-          </a:p>
-          <a:p>
-            <a:r>
-              <a:t>Say the correct verb form.</a:t>
-            </a:r>
-          </a:p>
-          <a:p/>
-          <a:p>
-            <a:r>
-              <a:t>EXPECTED ANSWERS / RESPONSES:</a:t>
-            </a:r>
-          </a:p>
-          <a:p>
-            <a:r>
-              <a:t>checks; is helping; lost; will double-check; learned/is learning (present: learns if daily)</a:t>
-            </a:r>
-          </a:p>
-          <a:p/>
-          <a:p>
-            <a:r>
-              <a:t>COMMON MISTAKES:</a:t>
-            </a:r>
-          </a:p>
-          <a:p>
-            <a:r>
-              <a:t>For #5 accept 'learns' if habitual present.</a:t>
-            </a:r>
-          </a:p>
-          <a:p/>
-          <a:p>
-            <a:r>
-              <a:t>ASSESSMENT TIPS:</a:t>
-            </a:r>
-          </a:p>
-          <a:p>
-            <a:r>
-              <a:t>Accuracy under light pressure.</a:t>
-            </a:r>
-          </a:p>
-          <a:p/>
-          <a:p>
-            <a:r>
-              <a:t>EXTENSION QUESTIONS:</a:t>
-            </a:r>
-          </a:p>
-          <a:p>
-            <a:r>
-              <a:t>Make your own sentence in past tense.</a:t>
-            </a:r>
-          </a:p>
-          <a:p/>
-          <a:p>
-            <a:r>
-              <a:t>TIMING: Grammar block</a:t>
-            </a:r>
-          </a:p>
         </p:txBody>
       </p:sp>
       <p:sp>
@@ -937,77 +727,7 @@
         <p:txBody>
           <a:bodyPr/>
           <a:lstStyle/>
-          <a:p>
-            <a:r>
-              <a:t>WHAT TO SAY:</a:t>
-            </a:r>
-          </a:p>
-          <a:p>
-            <a:r>
-              <a:t>Detective theme—ding when fixed!</a:t>
-            </a:r>
-          </a:p>
           <a:p/>
-          <a:p>
-            <a:r>
-              <a:t>STUDENT ACTIVITY:</a:t>
-            </a:r>
-          </a:p>
-          <a:p>
-            <a:r>
-              <a:t>Spot error + say corrected sentence.</a:t>
-            </a:r>
-          </a:p>
-          <a:p/>
-          <a:p>
-            <a:r>
-              <a:t>EXPECTED ANSWERS / RESPONSES:</a:t>
-            </a:r>
-          </a:p>
-          <a:p>
-            <a:r>
-              <a:t>1 Leo found/will find 2 is reading 3 will go 4 OK 5 helped</a:t>
-            </a:r>
-          </a:p>
-          <a:p/>
-          <a:p>
-            <a:r>
-              <a:t>COMMON MISTAKES:</a:t>
-            </a:r>
-          </a:p>
-          <a:p>
-            <a:r>
-              <a:t>Changing correct #4.</a:t>
-            </a:r>
-          </a:p>
-          <a:p/>
-          <a:p>
-            <a:r>
-              <a:t>ASSESSMENT TIPS:</a:t>
-            </a:r>
-          </a:p>
-          <a:p>
-            <a:r>
-              <a:t>Error detection.</a:t>
-            </a:r>
-          </a:p>
-          <a:p/>
-          <a:p>
-            <a:r>
-              <a:t>EXTENSION QUESTIONS:</a:t>
-            </a:r>
-          </a:p>
-          <a:p>
-            <a:r>
-              <a:t>Write one 'wrong' sentence for teacher to fix.</a:t>
-            </a:r>
-          </a:p>
-          <a:p/>
-          <a:p>
-            <a:r>
-              <a:t>TIMING: Grammar 25 min</a:t>
-            </a:r>
-          </a:p>
         </p:txBody>
       </p:sp>
       <p:sp>
@@ -1073,77 +793,7 @@
         <p:txBody>
           <a:bodyPr/>
           <a:lstStyle/>
-          <a:p>
-            <a:r>
-              <a:t>WHAT TO SAY:</a:t>
-            </a:r>
-          </a:p>
-          <a:p>
-            <a:r>
-              <a:t>Use dice or random number 1–4.</a:t>
-            </a:r>
-          </a:p>
           <a:p/>
-          <a:p>
-            <a:r>
-              <a:t>STUDENT ACTIVITY:</a:t>
-            </a:r>
-          </a:p>
-          <a:p>
-            <a:r>
-              <a:t>4 rounds of sentence building.</a:t>
-            </a:r>
-          </a:p>
-          <a:p/>
-          <a:p>
-            <a:r>
-              <a:t>EXPECTED ANSWERS / RESPONSES:</a:t>
-            </a:r>
-          </a:p>
-          <a:p>
-            <a:r>
-              <a:t>Grammatically sensible sentences.</a:t>
-            </a:r>
-          </a:p>
-          <a:p/>
-          <a:p>
-            <a:r>
-              <a:t>COMMON MISTAKES:</a:t>
-            </a:r>
-          </a:p>
-          <a:p>
-            <a:r>
-              <a:t>Adjective used as verb.</a:t>
-            </a:r>
-          </a:p>
-          <a:p/>
-          <a:p>
-            <a:r>
-              <a:t>ASSESSMENT TIPS:</a:t>
-            </a:r>
-          </a:p>
-          <a:p>
-            <a:r>
-              <a:t>Parts of speech in production.</a:t>
-            </a:r>
-          </a:p>
-          <a:p/>
-          <a:p>
-            <a:r>
-              <a:t>EXTENSION QUESTIONS:</a:t>
-            </a:r>
-          </a:p>
-          <a:p>
-            <a:r>
-              <a:t>Add a second adjective.</a:t>
-            </a:r>
-          </a:p>
-          <a:p/>
-          <a:p>
-            <a:r>
-              <a:t>TIMING: Grammar games</a:t>
-            </a:r>
-          </a:p>
         </p:txBody>
       </p:sp>
       <p:sp>
@@ -1209,77 +859,7 @@
         <p:txBody>
           <a:bodyPr/>
           <a:lstStyle/>
-          <a:p>
-            <a:r>
-              <a:t>WHAT TO SAY:</a:t>
-            </a:r>
-          </a:p>
-          <a:p>
-            <a:r>
-              <a:t>Explain re- = again; -ful = full of.</a:t>
-            </a:r>
-          </a:p>
           <a:p/>
-          <a:p>
-            <a:r>
-              <a:t>STUDENT ACTIVITY:</a:t>
-            </a:r>
-          </a:p>
-          <a:p>
-            <a:r>
-              <a:t>Create 3 new examples aloud.</a:t>
-            </a:r>
-          </a:p>
-          <a:p/>
-          <a:p>
-            <a:r>
-              <a:t>EXPECTED ANSWERS / RESPONSES:</a:t>
-            </a:r>
-          </a:p>
-          <a:p>
-            <a:r>
-              <a:t>Reasonable word formations.</a:t>
-            </a:r>
-          </a:p>
-          <a:p/>
-          <a:p>
-            <a:r>
-              <a:t>COMMON MISTAKES:</a:t>
-            </a:r>
-          </a:p>
-          <a:p>
-            <a:r>
-              <a:t>Invalid compounds.</a:t>
-            </a:r>
-          </a:p>
-          <a:p/>
-          <a:p>
-            <a:r>
-              <a:t>ASSESSMENT TIPS:</a:t>
-            </a:r>
-          </a:p>
-          <a:p>
-            <a:r>
-              <a:t>Morphology awareness.</a:t>
-            </a:r>
-          </a:p>
-          <a:p/>
-          <a:p>
-            <a:r>
-              <a:t>EXTENSION QUESTIONS:</a:t>
-            </a:r>
-          </a:p>
-          <a:p>
-            <a:r>
-              <a:t>Use 'helpful' about Mystery Helper.</a:t>
-            </a:r>
-          </a:p>
-          <a:p/>
-          <a:p>
-            <a:r>
-              <a:t>TIMING: Vocab 10 min</a:t>
-            </a:r>
-          </a:p>
         </p:txBody>
       </p:sp>
       <p:sp>
@@ -1345,77 +925,7 @@
         <p:txBody>
           <a:bodyPr/>
           <a:lstStyle/>
-          <a:p>
-            <a:r>
-              <a:t>WHAT TO SAY:</a:t>
-            </a:r>
-          </a:p>
-          <a:p>
-            <a:r>
-              <a:t>Timer 3 minutes—game feel!</a:t>
-            </a:r>
-          </a:p>
           <a:p/>
-          <a:p>
-            <a:r>
-              <a:t>STUDENT ACTIVITY:</a:t>
-            </a:r>
-          </a:p>
-          <a:p>
-            <a:r>
-              <a:t>Circle words on screen or paper.</a:t>
-            </a:r>
-          </a:p>
-          <a:p/>
-          <a:p>
-            <a:r>
-              <a:t>EXPECTED ANSWERS / RESPONSES:</a:t>
-            </a:r>
-          </a:p>
-          <a:p>
-            <a:r>
-              <a:t>Finds 4+ words.</a:t>
-            </a:r>
-          </a:p>
-          <a:p/>
-          <a:p>
-            <a:r>
-              <a:t>COMMON MISTAKES:</a:t>
-            </a:r>
-          </a:p>
-          <a:p>
-            <a:r>
-              <a:t>Spelling confusion.</a:t>
-            </a:r>
-          </a:p>
-          <a:p/>
-          <a:p>
-            <a:r>
-              <a:t>ASSESSMENT TIPS:</a:t>
-            </a:r>
-          </a:p>
-          <a:p>
-            <a:r>
-              <a:t>Word recognition speed.</a:t>
-            </a:r>
-          </a:p>
-          <a:p/>
-          <a:p>
-            <a:r>
-              <a:t>EXTENSION QUESTIONS:</a:t>
-            </a:r>
-          </a:p>
-          <a:p>
-            <a:r>
-              <a:t>Use FUTURE in a sentence.</a:t>
-            </a:r>
-          </a:p>
-          <a:p/>
-          <a:p>
-            <a:r>
-              <a:t>TIMING: Vocab games</a:t>
-            </a:r>
-          </a:p>
         </p:txBody>
       </p:sp>
       <p:sp>
@@ -1481,77 +991,7 @@
         <p:txBody>
           <a:bodyPr/>
           <a:lstStyle/>
-          <a:p>
-            <a:r>
-              <a:t>WHAT TO SAY:</a:t>
-            </a:r>
-          </a:p>
-          <a:p>
-            <a:r>
-              <a:t>Reveal answers after attempt—or hide bottom line during play.</a:t>
-            </a:r>
-          </a:p>
           <a:p/>
-          <a:p>
-            <a:r>
-              <a:t>STUDENT ACTIVITY:</a:t>
-            </a:r>
-          </a:p>
-          <a:p>
-            <a:r>
-              <a:t>Solve clues aloud.</a:t>
-            </a:r>
-          </a:p>
-          <a:p/>
-          <a:p>
-            <a:r>
-              <a:t>EXPECTED ANSWERS / RESPONSES:</a:t>
-            </a:r>
-          </a:p>
-          <a:p>
-            <a:r>
-              <a:t>See bottom line (teacher key).</a:t>
-            </a:r>
-          </a:p>
-          <a:p/>
-          <a:p>
-            <a:r>
-              <a:t>COMMON MISTAKES:</a:t>
-            </a:r>
-          </a:p>
-          <a:p>
-            <a:r>
-              <a:t>Letter count ignored.</a:t>
-            </a:r>
-          </a:p>
-          <a:p/>
-          <a:p>
-            <a:r>
-              <a:t>ASSESSMENT TIPS:</a:t>
-            </a:r>
-          </a:p>
-          <a:p>
-            <a:r>
-              <a:t>Spelling + meaning.</a:t>
-            </a:r>
-          </a:p>
-          <a:p/>
-          <a:p>
-            <a:r>
-              <a:t>EXTENSION QUESTIONS:</a:t>
-            </a:r>
-          </a:p>
-          <a:p>
-            <a:r>
-              <a:t>Create one new clue.</a:t>
-            </a:r>
-          </a:p>
-          <a:p/>
-          <a:p>
-            <a:r>
-              <a:t>TIMING: Vocab</a:t>
-            </a:r>
-          </a:p>
         </p:txBody>
       </p:sp>
       <p:sp>
@@ -1617,77 +1057,7 @@
         <p:txBody>
           <a:bodyPr/>
           <a:lstStyle/>
-          <a:p>
-            <a:r>
-              <a:t>WHAT TO SAY:</a:t>
-            </a:r>
-          </a:p>
-          <a:p>
-            <a:r>
-              <a:t>Cover screen after 20 sec.</a:t>
-            </a:r>
-          </a:p>
           <a:p/>
-          <a:p>
-            <a:r>
-              <a:t>STUDENT ACTIVITY:</a:t>
-            </a:r>
-          </a:p>
-          <a:p>
-            <a:r>
-              <a:t>Recall list; compare.</a:t>
-            </a:r>
-          </a:p>
-          <a:p/>
-          <a:p>
-            <a:r>
-              <a:t>EXPECTED ANSWERS / RESPONSES:</a:t>
-            </a:r>
-          </a:p>
-          <a:p>
-            <a:r>
-              <a:t>6+ items strong; 4+ OK.</a:t>
-            </a:r>
-          </a:p>
-          <a:p/>
-          <a:p>
-            <a:r>
-              <a:t>COMMON MISTAKES:</a:t>
-            </a:r>
-          </a:p>
-          <a:p>
-            <a:r>
-              <a:t>Random guessing.</a:t>
-            </a:r>
-          </a:p>
-          <a:p/>
-          <a:p>
-            <a:r>
-              <a:t>ASSESSMENT TIPS:</a:t>
-            </a:r>
-          </a:p>
-          <a:p>
-            <a:r>
-              <a:t>Working memory, speaking.</a:t>
-            </a:r>
-          </a:p>
-          <a:p/>
-          <a:p>
-            <a:r>
-              <a:t>EXTENSION QUESTIONS:</a:t>
-            </a:r>
-          </a:p>
-          <a:p>
-            <a:r>
-              <a:t>Which item was hardest?</a:t>
-            </a:r>
-          </a:p>
-          <a:p/>
-          <a:p>
-            <a:r>
-              <a:t>TIMING: Every 5–7 min activity</a:t>
-            </a:r>
-          </a:p>
         </p:txBody>
       </p:sp>
       <p:sp>
@@ -1753,77 +1123,7 @@
         <p:txBody>
           <a:bodyPr/>
           <a:lstStyle/>
-          <a:p>
-            <a:r>
-              <a:t>WHAT TO SAY:</a:t>
-            </a:r>
-          </a:p>
-          <a:p>
-            <a:r>
-              <a:t>90-second description.</a:t>
-            </a:r>
-          </a:p>
           <a:p/>
-          <a:p>
-            <a:r>
-              <a:t>STUDENT ACTIVITY:</a:t>
-            </a:r>
-          </a:p>
-          <a:p>
-            <a:r>
-              <a:t>Cover all 4 boxes.</a:t>
-            </a:r>
-          </a:p>
-          <a:p/>
-          <a:p>
-            <a:r>
-              <a:t>EXPECTED ANSWERS / RESPONSES:</a:t>
-            </a:r>
-          </a:p>
-          <a:p>
-            <a:r>
-              <a:t>Uses adjectives + present continuous.</a:t>
-            </a:r>
-          </a:p>
-          <a:p/>
-          <a:p>
-            <a:r>
-              <a:t>COMMON MISTAKES:</a:t>
-            </a:r>
-          </a:p>
-          <a:p>
-            <a:r>
-              <a:t>Only listing nouns.</a:t>
-            </a:r>
-          </a:p>
-          <a:p/>
-          <a:p>
-            <a:r>
-              <a:t>ASSESSMENT TIPS:</a:t>
-            </a:r>
-          </a:p>
-          <a:p>
-            <a:r>
-              <a:t>Descriptive language.</a:t>
-            </a:r>
-          </a:p>
-          <a:p/>
-          <a:p>
-            <a:r>
-              <a:t>EXTENSION QUESTIONS:</a:t>
-            </a:r>
-          </a:p>
-          <a:p>
-            <a:r>
-              <a:t>What might happen next in the park?</a:t>
-            </a:r>
-          </a:p>
-          <a:p/>
-          <a:p>
-            <a:r>
-              <a:t>TIMING: Speaking 10 min</a:t>
-            </a:r>
-          </a:p>
         </p:txBody>
       </p:sp>
       <p:sp>
@@ -1889,77 +1189,7 @@
         <p:txBody>
           <a:bodyPr/>
           <a:lstStyle/>
-          <a:p>
-            <a:r>
-              <a:t>WHAT TO SAY:</a:t>
-            </a:r>
-          </a:p>
-          <a:p>
-            <a:r>
-              <a:t>Roll dice or pick 3 cards.</a:t>
-            </a:r>
-          </a:p>
           <a:p/>
-          <a:p>
-            <a:r>
-              <a:t>STUDENT ACTIVITY:</a:t>
-            </a:r>
-          </a:p>
-          <a:p>
-            <a:r>
-              <a:t>5-sentence original story.</a:t>
-            </a:r>
-          </a:p>
-          <a:p/>
-          <a:p>
-            <a:r>
-              <a:t>EXPECTED ANSWERS / RESPONSES:</a:t>
-            </a:r>
-          </a:p>
-          <a:p>
-            <a:r>
-              <a:t>Coherent plot.</a:t>
-            </a:r>
-          </a:p>
-          <a:p/>
-          <a:p>
-            <a:r>
-              <a:t>COMMON MISTAKES:</a:t>
-            </a:r>
-          </a:p>
-          <a:p>
-            <a:r>
-              <a:t>No ending.</a:t>
-            </a:r>
-          </a:p>
-          <a:p/>
-          <a:p>
-            <a:r>
-              <a:t>ASSESSMENT TIPS:</a:t>
-            </a:r>
-          </a:p>
-          <a:p>
-            <a:r>
-              <a:t>Creativity + grammar in speech.</a:t>
-            </a:r>
-          </a:p>
-          <a:p/>
-          <a:p>
-            <a:r>
-              <a:t>EXTENSION QUESTIONS:</a:t>
-            </a:r>
-          </a:p>
-          <a:p>
-            <a:r>
-              <a:t>Add dialogue.</a:t>
-            </a:r>
-          </a:p>
-          <a:p/>
-          <a:p>
-            <a:r>
-              <a:t>TIMING: Storytelling</a:t>
-            </a:r>
-          </a:p>
         </p:txBody>
       </p:sp>
       <p:sp>
@@ -2025,77 +1255,7 @@
         <p:txBody>
           <a:bodyPr/>
           <a:lstStyle/>
-          <a:p>
-            <a:r>
-              <a:t>WHAT TO SAY:</a:t>
-            </a:r>
-          </a:p>
-          <a:p>
-            <a:r>
-              <a:t>Share warmly, then invite Sage to answer one question at a time.</a:t>
-            </a:r>
-          </a:p>
           <a:p/>
-          <a:p>
-            <a:r>
-              <a:t>STUDENT ACTIVITY:</a:t>
-            </a:r>
-          </a:p>
-          <a:p>
-            <a:r>
-              <a:t>Answer 3 questions in full sentences.</a:t>
-            </a:r>
-          </a:p>
-          <a:p/>
-          <a:p>
-            <a:r>
-              <a:t>EXPECTED ANSWERS / RESPONSES:</a:t>
-            </a:r>
-          </a:p>
-          <a:p>
-            <a:r>
-              <a:t>Animal/movie/superpower with short reason.</a:t>
-            </a:r>
-          </a:p>
-          <a:p/>
-          <a:p>
-            <a:r>
-              <a:t>COMMON MISTAKES:</a:t>
-            </a:r>
-          </a:p>
-          <a:p>
-            <a:r>
-              <a:t>Listing without because.</a:t>
-            </a:r>
-          </a:p>
-          <a:p/>
-          <a:p>
-            <a:r>
-              <a:t>ASSESSMENT TIPS:</a:t>
-            </a:r>
-          </a:p>
-          <a:p>
-            <a:r>
-              <a:t>Fluency, pronunciation, confidence—not perfection.</a:t>
-            </a:r>
-          </a:p>
-          <a:p/>
-          <a:p>
-            <a:r>
-              <a:t>EXTENSION QUESTIONS:</a:t>
-            </a:r>
-          </a:p>
-          <a:p>
-            <a:r>
-              <a:t>Why that animal? What would you do with that power?</a:t>
-            </a:r>
-          </a:p>
-          <a:p/>
-          <a:p>
-            <a:r>
-              <a:t>TIMING: 5 min</a:t>
-            </a:r>
-          </a:p>
         </p:txBody>
       </p:sp>
       <p:sp>
@@ -2161,77 +1321,7 @@
         <p:txBody>
           <a:bodyPr/>
           <a:lstStyle/>
-          <a:p>
-            <a:r>
-              <a:t>WHAT TO SAY:</a:t>
-            </a:r>
-          </a:p>
-          <a:p>
-            <a:r>
-              <a:t>Sage picks 1 role; teacher plays partner.</a:t>
-            </a:r>
-          </a:p>
           <a:p/>
-          <a:p>
-            <a:r>
-              <a:t>STUDENT ACTIVITY:</a:t>
-            </a:r>
-          </a:p>
-          <a:p>
-            <a:r>
-              <a:t>45–60 second role play.</a:t>
-            </a:r>
-          </a:p>
-          <a:p/>
-          <a:p>
-            <a:r>
-              <a:t>EXPECTED ANSWERS / RESPONSES:</a:t>
-            </a:r>
-          </a:p>
-          <a:p>
-            <a:r>
-              <a:t>Appropriate phrases (May I…, Could you…).</a:t>
-            </a:r>
-          </a:p>
-          <a:p/>
-          <a:p>
-            <a:r>
-              <a:t>COMMON MISTAKES:</a:t>
-            </a:r>
-          </a:p>
-          <a:p>
-            <a:r>
-              <a:t>Too quiet in library scene.</a:t>
-            </a:r>
-          </a:p>
-          <a:p/>
-          <a:p>
-            <a:r>
-              <a:t>ASSESSMENT TIPS:</a:t>
-            </a:r>
-          </a:p>
-          <a:p>
-            <a:r>
-              <a:t>Pragmatics, confidence.</a:t>
-            </a:r>
-          </a:p>
-          <a:p/>
-          <a:p>
-            <a:r>
-              <a:t>EXTENSION QUESTIONS:</a:t>
-            </a:r>
-          </a:p>
-          <a:p>
-            <a:r>
-              <a:t>Switch roles quickly.</a:t>
-            </a:r>
-          </a:p>
-          <a:p/>
-          <a:p>
-            <a:r>
-              <a:t>TIMING: Speaking block</a:t>
-            </a:r>
-          </a:p>
         </p:txBody>
       </p:sp>
       <p:sp>
@@ -2297,77 +1387,7 @@
         <p:txBody>
           <a:bodyPr/>
           <a:lstStyle/>
-          <a:p>
-            <a:r>
-              <a:t>WHAT TO SAY:</a:t>
-            </a:r>
-          </a:p>
-          <a:p>
-            <a:r>
-              <a:t>Slow → medium → fast.</a:t>
-            </a:r>
-          </a:p>
           <a:p/>
-          <a:p>
-            <a:r>
-              <a:t>STUDENT ACTIVITY:</a:t>
-            </a:r>
-          </a:p>
-          <a:p>
-            <a:r>
-              <a:t>Repeat each 3 times.</a:t>
-            </a:r>
-          </a:p>
-          <a:p/>
-          <a:p>
-            <a:r>
-              <a:t>EXPECTED ANSWERS / RESPONSES:</a:t>
-            </a:r>
-          </a:p>
-          <a:p>
-            <a:r>
-              <a:t>Clearer consonants over time.</a:t>
-            </a:r>
-          </a:p>
-          <a:p/>
-          <a:p>
-            <a:r>
-              <a:t>COMMON MISTAKES:</a:t>
-            </a:r>
-          </a:p>
-          <a:p>
-            <a:r>
-              <a:t>Frustration—keep it fun.</a:t>
-            </a:r>
-          </a:p>
-          <a:p/>
-          <a:p>
-            <a:r>
-              <a:t>ASSESSMENT TIPS:</a:t>
-            </a:r>
-          </a:p>
-          <a:p>
-            <a:r>
-              <a:t>Pronunciation playfulness.</a:t>
-            </a:r>
-          </a:p>
-          <a:p/>
-          <a:p>
-            <a:r>
-              <a:t>EXTENSION QUESTIONS:</a:t>
-            </a:r>
-          </a:p>
-          <a:p>
-            <a:r>
-              <a:t>Clap the rhythm.</a:t>
-            </a:r>
-          </a:p>
-          <a:p/>
-          <a:p>
-            <a:r>
-              <a:t>TIMING: Flex within 90 min</a:t>
-            </a:r>
-          </a:p>
         </p:txBody>
       </p:sp>
       <p:sp>
@@ -2433,77 +1453,7 @@
         <p:txBody>
           <a:bodyPr/>
           <a:lstStyle/>
-          <a:p>
-            <a:r>
-              <a:t>WHAT TO SAY:</a:t>
-            </a:r>
-          </a:p>
-          <a:p>
-            <a:r>
-              <a:t>Read twice; second time Sage may take notes.</a:t>
-            </a:r>
-          </a:p>
           <a:p/>
-          <a:p>
-            <a:r>
-              <a:t>STUDENT ACTIVITY:</a:t>
-            </a:r>
-          </a:p>
-          <a:p>
-            <a:r>
-              <a:t>Answer 4 questions without looking at passage.</a:t>
-            </a:r>
-          </a:p>
-          <a:p/>
-          <a:p>
-            <a:r>
-              <a:t>EXPECTED ANSWERS / RESPONSES:</a:t>
-            </a:r>
-          </a:p>
-          <a:p>
-            <a:r>
-              <a:t>Reading festival; poster; second; fruit popsicles.</a:t>
-            </a:r>
-          </a:p>
-          <a:p/>
-          <a:p>
-            <a:r>
-              <a:t>COMMON MISTAKES:</a:t>
-            </a:r>
-          </a:p>
-          <a:p>
-            <a:r>
-              <a:t>Copying irrelevant details.</a:t>
-            </a:r>
-          </a:p>
-          <a:p/>
-          <a:p>
-            <a:r>
-              <a:t>ASSESSMENT TIPS:</a:t>
-            </a:r>
-          </a:p>
-          <a:p>
-            <a:r>
-              <a:t>Listening comprehension.</a:t>
-            </a:r>
-          </a:p>
-          <a:p/>
-          <a:p>
-            <a:r>
-              <a:t>EXTENSION QUESTIONS:</a:t>
-            </a:r>
-          </a:p>
-          <a:p>
-            <a:r>
-              <a:t>What was the main idea?</a:t>
-            </a:r>
-          </a:p>
-          <a:p/>
-          <a:p>
-            <a:r>
-              <a:t>TIMING: Listening skill</a:t>
-            </a:r>
-          </a:p>
         </p:txBody>
       </p:sp>
       <p:sp>
@@ -2569,77 +1519,7 @@
         <p:txBody>
           <a:bodyPr/>
           <a:lstStyle/>
-          <a:p>
-            <a:r>
-              <a:t>WHAT TO SAY:</a:t>
-            </a:r>
-          </a:p>
-          <a:p>
-            <a:r>
-              <a:t>Lightning round—10 sec think time each.</a:t>
-            </a:r>
-          </a:p>
           <a:p/>
-          <a:p>
-            <a:r>
-              <a:t>STUDENT ACTIVITY:</a:t>
-            </a:r>
-          </a:p>
-          <a:p>
-            <a:r>
-              <a:t>Say corrected sentence.</a:t>
-            </a:r>
-          </a:p>
-          <a:p/>
-          <a:p>
-            <a:r>
-              <a:t>EXPECTED ANSWERS / RESPONSES:</a:t>
-            </a:r>
-          </a:p>
-          <a:p>
-            <a:r>
-              <a:t>goes; is looking; lost; will help; was solved</a:t>
-            </a:r>
-          </a:p>
-          <a:p/>
-          <a:p>
-            <a:r>
-              <a:t>COMMON MISTAKES:</a:t>
-            </a:r>
-          </a:p>
-          <a:p>
-            <a:r>
-              <a:t>Only naming error type.</a:t>
-            </a:r>
-          </a:p>
-          <a:p/>
-          <a:p>
-            <a:r>
-              <a:t>ASSESSMENT TIPS:</a:t>
-            </a:r>
-          </a:p>
-          <a:p>
-            <a:r>
-              <a:t>Tense + agreement.</a:t>
-            </a:r>
-          </a:p>
-          <a:p/>
-          <a:p>
-            <a:r>
-              <a:t>EXTENSION QUESTIONS:</a:t>
-            </a:r>
-          </a:p>
-          <a:p>
-            <a:r>
-              <a:t>Write one mistake for teacher.</a:t>
-            </a:r>
-          </a:p>
-          <a:p/>
-          <a:p>
-            <a:r>
-              <a:t>TIMING: Grammar games</a:t>
-            </a:r>
-          </a:p>
         </p:txBody>
       </p:sp>
       <p:sp>
@@ -2705,77 +1585,7 @@
         <p:txBody>
           <a:bodyPr/>
           <a:lstStyle/>
-          <a:p>
-            <a:r>
-              <a:t>WHAT TO SAY:</a:t>
-            </a:r>
-          </a:p>
-          <a:p>
-            <a:r>
-              <a:t>Score with fingers/stars—no stress.</a:t>
-            </a:r>
-          </a:p>
           <a:p/>
-          <a:p>
-            <a:r>
-              <a:t>STUDENT ACTIVITY:</a:t>
-            </a:r>
-          </a:p>
-          <a:p>
-            <a:r>
-              <a:t>Quick verbal answers.</a:t>
-            </a:r>
-          </a:p>
-          <a:p/>
-          <a:p>
-            <a:r>
-              <a:t>EXPECTED ANSWERS / RESPONSES:</a:t>
-            </a:r>
-          </a:p>
-          <a:p>
-            <a:r>
-              <a:t>found; Present Continuous; glad; blue; will</a:t>
-            </a:r>
-          </a:p>
-          <a:p/>
-          <a:p>
-            <a:r>
-              <a:t>COMMON MISTAKES:</a:t>
-            </a:r>
-          </a:p>
-          <a:p>
-            <a:r>
-              <a:t>Rushing.</a:t>
-            </a:r>
-          </a:p>
-          <a:p/>
-          <a:p>
-            <a:r>
-              <a:t>ASSESSMENT TIPS:</a:t>
-            </a:r>
-          </a:p>
-          <a:p>
-            <a:r>
-              <a:t>Retention check.</a:t>
-            </a:r>
-          </a:p>
-          <a:p/>
-          <a:p>
-            <a:r>
-              <a:t>EXTENSION QUESTIONS:</a:t>
-            </a:r>
-          </a:p>
-          <a:p>
-            <a:r>
-              <a:t>Make up Q6.</a:t>
-            </a:r>
-          </a:p>
-          <a:p/>
-          <a:p>
-            <a:r>
-              <a:t>TIMING: Games 5 min</a:t>
-            </a:r>
-          </a:p>
         </p:txBody>
       </p:sp>
       <p:sp>
@@ -2841,77 +1651,7 @@
         <p:txBody>
           <a:bodyPr/>
           <a:lstStyle/>
-          <a:p>
-            <a:r>
-              <a:t>WHAT TO SAY:</a:t>
-            </a:r>
-          </a:p>
-          <a:p>
-            <a:r>
-              <a:t>Read clues dramatically.</a:t>
-            </a:r>
-          </a:p>
           <a:p/>
-          <a:p>
-            <a:r>
-              <a:t>STUDENT ACTIVITY:</a:t>
-            </a:r>
-          </a:p>
-          <a:p>
-            <a:r>
-              <a:t>Shout answers; use in sentence.</a:t>
-            </a:r>
-          </a:p>
-          <a:p/>
-          <a:p>
-            <a:r>
-              <a:t>EXPECTED ANSWERS / RESPONSES:</a:t>
-            </a:r>
-          </a:p>
-          <a:p>
-            <a:r>
-              <a:t>See clue answers.</a:t>
-            </a:r>
-          </a:p>
-          <a:p/>
-          <a:p>
-            <a:r>
-              <a:t>COMMON MISTAKES:</a:t>
-            </a:r>
-          </a:p>
-          <a:p>
-            <a:r>
-              <a:t>Random words.</a:t>
-            </a:r>
-          </a:p>
-          <a:p/>
-          <a:p>
-            <a:r>
-              <a:t>ASSESSMENT TIPS:</a:t>
-            </a:r>
-          </a:p>
-          <a:p>
-            <a:r>
-              <a:t>Vocab recall.</a:t>
-            </a:r>
-          </a:p>
-          <a:p/>
-          <a:p>
-            <a:r>
-              <a:t>EXTENSION QUESTIONS:</a:t>
-            </a:r>
-          </a:p>
-          <a:p>
-            <a:r>
-              <a:t>Sage writes own clue.</a:t>
-            </a:r>
-          </a:p>
-          <a:p/>
-          <a:p>
-            <a:r>
-              <a:t>TIMING: Games</a:t>
-            </a:r>
-          </a:p>
         </p:txBody>
       </p:sp>
       <p:sp>
@@ -2977,77 +1717,7 @@
         <p:txBody>
           <a:bodyPr/>
           <a:lstStyle/>
-          <a:p>
-            <a:r>
-              <a:t>WHAT TO SAY:</a:t>
-            </a:r>
-          </a:p>
-          <a:p>
-            <a:r>
-              <a:t>Team vs clock—celebrate escape!</a:t>
-            </a:r>
-          </a:p>
           <a:p/>
-          <a:p>
-            <a:r>
-              <a:t>STUDENT ACTIVITY:</a:t>
-            </a:r>
-          </a:p>
-          <a:p>
-            <a:r>
-              <a:t>Solve all 5.</a:t>
-            </a:r>
-          </a:p>
-          <a:p/>
-          <a:p>
-            <a:r>
-              <a:t>EXPECTED ANSWERS / RESPONSES:</a:t>
-            </a:r>
-          </a:p>
-          <a:p>
-            <a:r>
-              <a:t>See key line (hide if needed).</a:t>
-            </a:r>
-          </a:p>
-          <a:p/>
-          <a:p>
-            <a:r>
-              <a:t>COMMON MISTAKES:</a:t>
-            </a:r>
-          </a:p>
-          <a:p>
-            <a:r>
-              <a:t>Giving up—offer hint.</a:t>
-            </a:r>
-          </a:p>
-          <a:p/>
-          <a:p>
-            <a:r>
-              <a:t>ASSESSMENT TIPS:</a:t>
-            </a:r>
-          </a:p>
-          <a:p>
-            <a:r>
-              <a:t>Integrated skills.</a:t>
-            </a:r>
-          </a:p>
-          <a:p/>
-          <a:p>
-            <a:r>
-              <a:t>EXTENSION QUESTIONS:</a:t>
-            </a:r>
-          </a:p>
-          <a:p>
-            <a:r>
-              <a:t>Design puzzle 6.</a:t>
-            </a:r>
-          </a:p>
-          <a:p/>
-          <a:p>
-            <a:r>
-              <a:t>TIMING: Games 5 min</a:t>
-            </a:r>
-          </a:p>
         </p:txBody>
       </p:sp>
       <p:sp>
@@ -3113,77 +1783,7 @@
         <p:txBody>
           <a:bodyPr/>
           <a:lstStyle/>
-          <a:p>
-            <a:r>
-              <a:t>WHAT TO SAY:</a:t>
-            </a:r>
-          </a:p>
-          <a:p>
-            <a:r>
-              <a:t>Complete privately—never make Sage feel graded.</a:t>
-            </a:r>
-          </a:p>
           <a:p/>
-          <a:p>
-            <a:r>
-              <a:t>STUDENT ACTIVITY:</a:t>
-            </a:r>
-          </a:p>
-          <a:p>
-            <a:r>
-              <a:t>Teacher observes and marks rubric.</a:t>
-            </a:r>
-          </a:p>
-          <a:p/>
-          <a:p>
-            <a:r>
-              <a:t>EXPECTED ANSWERS / RESPONSES:</a:t>
-            </a:r>
-          </a:p>
-          <a:p>
-            <a:r>
-              <a:t>1=emerging 5=strong for Grade 5 demo.</a:t>
-            </a:r>
-          </a:p>
-          <a:p/>
-          <a:p>
-            <a:r>
-              <a:t>COMMON MISTAKES:</a:t>
-            </a:r>
-          </a:p>
-          <a:p>
-            <a:r>
-              <a:t>Sharing scores aloud.</a:t>
-            </a:r>
-          </a:p>
-          <a:p/>
-          <a:p>
-            <a:r>
-              <a:t>ASSESSMENT TIPS:</a:t>
-            </a:r>
-          </a:p>
-          <a:p>
-            <a:r>
-              <a:t>Holistic demo assessment for parents.</a:t>
-            </a:r>
-          </a:p>
-          <a:p/>
-          <a:p>
-            <a:r>
-              <a:t>EXTENSION QUESTIONS:</a:t>
-            </a:r>
-          </a:p>
-          <a:p>
-            <a:r>
-              <a:t>Write 1 strength + 1 next step.</a:t>
-            </a:r>
-          </a:p>
-          <a:p/>
-          <a:p>
-            <a:r>
-              <a:t>TIMING: Throughout class</a:t>
-            </a:r>
-          </a:p>
         </p:txBody>
       </p:sp>
       <p:sp>
@@ -3249,77 +1849,7 @@
         <p:txBody>
           <a:bodyPr/>
           <a:lstStyle/>
-          <a:p>
-            <a:r>
-              <a:t>WHAT TO SAY:</a:t>
-            </a:r>
-          </a:p>
-          <a:p>
-            <a:r>
-              <a:t>Switch roles—Sage is the expert!</a:t>
-            </a:r>
-          </a:p>
           <a:p/>
-          <a:p>
-            <a:r>
-              <a:t>STUDENT ACTIVITY:</a:t>
-            </a:r>
-          </a:p>
-          <a:p>
-            <a:r>
-              <a:t>2-minute mini-lesson from student.</a:t>
-            </a:r>
-          </a:p>
-          <a:p/>
-          <a:p>
-            <a:r>
-              <a:t>EXPECTED ANSWERS / RESPONSES:</a:t>
-            </a:r>
-          </a:p>
-          <a:p>
-            <a:r>
-              <a:t>Accurate recap.</a:t>
-            </a:r>
-          </a:p>
-          <a:p/>
-          <a:p>
-            <a:r>
-              <a:t>COMMON MISTAKES:</a:t>
-            </a:r>
-          </a:p>
-          <a:p>
-            <a:r>
-              <a:t>I don't know.</a:t>
-            </a:r>
-          </a:p>
-          <a:p/>
-          <a:p>
-            <a:r>
-              <a:t>ASSESSMENT TIPS:</a:t>
-            </a:r>
-          </a:p>
-          <a:p>
-            <a:r>
-              <a:t>Metacognition + confidence.</a:t>
-            </a:r>
-          </a:p>
-          <a:p/>
-          <a:p>
-            <a:r>
-              <a:t>EXTENSION QUESTIONS:</a:t>
-            </a:r>
-          </a:p>
-          <a:p>
-            <a:r>
-              <a:t>What will you practice tomorrow?</a:t>
-            </a:r>
-          </a:p>
-          <a:p/>
-          <a:p>
-            <a:r>
-              <a:t>TIMING: Recap 5 min</a:t>
-            </a:r>
-          </a:p>
         </p:txBody>
       </p:sp>
       <p:sp>
@@ -3385,77 +1915,7 @@
         <p:txBody>
           <a:bodyPr/>
           <a:lstStyle/>
-          <a:p>
-            <a:r>
-              <a:t>WHAT TO SAY:</a:t>
-            </a:r>
-          </a:p>
-          <a:p>
-            <a:r>
-              <a:t>Keep homework fun—15–20 min max.</a:t>
-            </a:r>
-          </a:p>
           <a:p/>
-          <a:p>
-            <a:r>
-              <a:t>STUDENT ACTIVITY:</a:t>
-            </a:r>
-          </a:p>
-          <a:p>
-            <a:r>
-              <a:t>Plan orally before writing.</a:t>
-            </a:r>
-          </a:p>
-          <a:p/>
-          <a:p>
-            <a:r>
-              <a:t>EXPECTED ANSWERS / RESPONSES:</a:t>
-            </a:r>
-          </a:p>
-          <a:p>
-            <a:r>
-              <a:t>Paragraph with tense variety.</a:t>
-            </a:r>
-          </a:p>
-          <a:p/>
-          <a:p>
-            <a:r>
-              <a:t>COMMON MISTAKES:</a:t>
-            </a:r>
-          </a:p>
-          <a:p>
-            <a:r>
-              <a:t>All one tense.</a:t>
-            </a:r>
-          </a:p>
-          <a:p/>
-          <a:p>
-            <a:r>
-              <a:t>ASSESSMENT TIPS:</a:t>
-            </a:r>
-          </a:p>
-          <a:p>
-            <a:r>
-              <a:t>Transfer to independent work.</a:t>
-            </a:r>
-          </a:p>
-          <a:p/>
-          <a:p>
-            <a:r>
-              <a:t>EXTENSION QUESTIONS:</a:t>
-            </a:r>
-          </a:p>
-          <a:p>
-            <a:r>
-              <a:t>Where would you go first?</a:t>
-            </a:r>
-          </a:p>
-          <a:p/>
-          <a:p>
-            <a:r>
-              <a:t>TIMING: After class</a:t>
-            </a:r>
-          </a:p>
         </p:txBody>
       </p:sp>
       <p:sp>
@@ -3521,77 +1981,7 @@
         <p:txBody>
           <a:bodyPr/>
           <a:lstStyle/>
-          <a:p>
-            <a:r>
-              <a:t>WHAT TO SAY:</a:t>
-            </a:r>
-          </a:p>
-          <a:p>
-            <a:r>
-              <a:t>Pick 4 emojis. Model: 'I feel happy when…'</a:t>
-            </a:r>
-          </a:p>
           <a:p/>
-          <a:p>
-            <a:r>
-              <a:t>STUDENT ACTIVITY:</a:t>
-            </a:r>
-          </a:p>
-          <a:p>
-            <a:r>
-              <a:t>One sentence per emoji (4–8 total).</a:t>
-            </a:r>
-          </a:p>
-          <a:p/>
-          <a:p>
-            <a:r>
-              <a:t>EXPECTED ANSWERS / RESPONSES:</a:t>
-            </a:r>
-          </a:p>
-          <a:p>
-            <a:r>
-              <a:t>Subject + verb + detail.</a:t>
-            </a:r>
-          </a:p>
-          <a:p/>
-          <a:p>
-            <a:r>
-              <a:t>COMMON MISTAKES:</a:t>
-            </a:r>
-          </a:p>
-          <a:p>
-            <a:r>
-              <a:t>Fragment sentences.</a:t>
-            </a:r>
-          </a:p>
-          <a:p/>
-          <a:p>
-            <a:r>
-              <a:t>ASSESSMENT TIPS:</a:t>
-            </a:r>
-          </a:p>
-          <a:p>
-            <a:r>
-              <a:t>Sentence completeness, creativity.</a:t>
-            </a:r>
-          </a:p>
-          <a:p/>
-          <a:p>
-            <a:r>
-              <a:t>EXTENSION QUESTIONS:</a:t>
-            </a:r>
-          </a:p>
-          <a:p>
-            <a:r>
-              <a:t>Can you add an adjective?</a:t>
-            </a:r>
-          </a:p>
-          <a:p/>
-          <a:p>
-            <a:r>
-              <a:t>TIMING: Part of 10 min icebreaker block</a:t>
-            </a:r>
-          </a:p>
         </p:txBody>
       </p:sp>
       <p:sp>
@@ -3657,77 +2047,7 @@
         <p:txBody>
           <a:bodyPr/>
           <a:lstStyle/>
-          <a:p>
-            <a:r>
-              <a:t>WHAT TO SAY:</a:t>
-            </a:r>
-          </a:p>
-          <a:p>
-            <a:r>
-              <a:t>Big celebration! Specific praise (2 strengths).</a:t>
-            </a:r>
-          </a:p>
           <a:p/>
-          <a:p>
-            <a:r>
-              <a:t>STUDENT ACTIVITY:</a:t>
-            </a:r>
-          </a:p>
-          <a:p>
-            <a:r>
-              <a:t>Sage reads certificate title aloud.</a:t>
-            </a:r>
-          </a:p>
-          <a:p/>
-          <a:p>
-            <a:r>
-              <a:t>EXPECTED ANSWERS / RESPONSES:</a:t>
-            </a:r>
-          </a:p>
-          <a:p>
-            <a:r>
-              <a:t>Smiles, pride, willingness to return.</a:t>
-            </a:r>
-          </a:p>
-          <a:p/>
-          <a:p>
-            <a:r>
-              <a:t>COMMON MISTAKES:</a:t>
-            </a:r>
-          </a:p>
-          <a:p>
-            <a:r>
-              <a:t>Rushing out.</a:t>
-            </a:r>
-          </a:p>
-          <a:p/>
-          <a:p>
-            <a:r>
-              <a:t>ASSESSMENT TIPS:</a:t>
-            </a:r>
-          </a:p>
-          <a:p>
-            <a:r>
-              <a:t>End on high energy for parents.</a:t>
-            </a:r>
-          </a:p>
-          <a:p/>
-          <a:p>
-            <a:r>
-              <a:t>EXTENSION QUESTIONS:</a:t>
-            </a:r>
-          </a:p>
-          <a:p>
-            <a:r>
-              <a:t>What game do you want next time?</a:t>
-            </a:r>
-          </a:p>
-          <a:p/>
-          <a:p>
-            <a:r>
-              <a:t>TIMING: End</a:t>
-            </a:r>
-          </a:p>
         </p:txBody>
       </p:sp>
       <p:sp>
@@ -3793,77 +2113,7 @@
         <p:txBody>
           <a:bodyPr/>
           <a:lstStyle/>
-          <a:p>
-            <a:r>
-              <a:t>WHAT TO SAY:</a:t>
-            </a:r>
-          </a:p>
-          <a:p>
-            <a:r>
-              <a:t>Do 5–6 questions. Celebrate reasons!</a:t>
-            </a:r>
-          </a:p>
           <a:p/>
-          <a:p>
-            <a:r>
-              <a:t>STUDENT ACTIVITY:</a:t>
-            </a:r>
-          </a:p>
-          <a:p>
-            <a:r>
-              <a:t>Choose + explain why.</a:t>
-            </a:r>
-          </a:p>
-          <a:p/>
-          <a:p>
-            <a:r>
-              <a:t>EXPECTED ANSWERS / RESPONSES:</a:t>
-            </a:r>
-          </a:p>
-          <a:p>
-            <a:r>
-              <a:t>Full sentence with because.</a:t>
-            </a:r>
-          </a:p>
-          <a:p/>
-          <a:p>
-            <a:r>
-              <a:t>COMMON MISTAKES:</a:t>
-            </a:r>
-          </a:p>
-          <a:p>
-            <a:r>
-              <a:t>No reason given.</a:t>
-            </a:r>
-          </a:p>
-          <a:p/>
-          <a:p>
-            <a:r>
-              <a:t>ASSESSMENT TIPS:</a:t>
-            </a:r>
-          </a:p>
-          <a:p>
-            <a:r>
-              <a:t>Speaking confidence, reasoning.</a:t>
-            </a:r>
-          </a:p>
-          <a:p/>
-          <a:p>
-            <a:r>
-              <a:t>EXTENSION QUESTIONS:</a:t>
-            </a:r>
-          </a:p>
-          <a:p>
-            <a:r>
-              <a:t>What is the downside of your choice?</a:t>
-            </a:r>
-          </a:p>
-          <a:p/>
-          <a:p>
-            <a:r>
-              <a:t>TIMING: Icebreaker 10 min total</a:t>
-            </a:r>
-          </a:p>
         </p:txBody>
       </p:sp>
       <p:sp>
@@ -3929,77 +2179,7 @@
         <p:txBody>
           <a:bodyPr/>
           <a:lstStyle/>
-          <a:p>
-            <a:r>
-              <a:t>WHAT TO SAY:</a:t>
-            </a:r>
-          </a:p>
-          <a:p>
-            <a:r>
-              <a:t>Treat picture as interactive hunt.</a:t>
-            </a:r>
-          </a:p>
           <a:p/>
-          <a:p>
-            <a:r>
-              <a:t>STUDENT ACTIVITY:</a:t>
-            </a:r>
-          </a:p>
-          <a:p>
-            <a:r>
-              <a:t>Find words; 6 sentences aloud.</a:t>
-            </a:r>
-          </a:p>
-          <a:p/>
-          <a:p>
-            <a:r>
-              <a:t>EXPECTED ANSWERS / RESPONSES:</a:t>
-            </a:r>
-          </a:p>
-          <a:p>
-            <a:r>
-              <a:t>Uses target words correctly.</a:t>
-            </a:r>
-          </a:p>
-          <a:p/>
-          <a:p>
-            <a:r>
-              <a:t>COMMON MISTAKES:</a:t>
-            </a:r>
-          </a:p>
-          <a:p>
-            <a:r>
-              <a:t>Confuses clue/clueless.</a:t>
-            </a:r>
-          </a:p>
-          <a:p/>
-          <a:p>
-            <a:r>
-              <a:t>ASSESSMENT TIPS:</a:t>
-            </a:r>
-          </a:p>
-          <a:p>
-            <a:r>
-              <a:t>Vocabulary activation before reading.</a:t>
-            </a:r>
-          </a:p>
-          <a:p/>
-          <a:p>
-            <a:r>
-              <a:t>EXTENSION QUESTIONS:</a:t>
-            </a:r>
-          </a:p>
-          <a:p>
-            <a:r>
-              <a:t>Use 'mystery' in a sentence about Leo.</a:t>
-            </a:r>
-          </a:p>
-          <a:p/>
-          <a:p>
-            <a:r>
-              <a:t>TIMING: Vocab block</a:t>
-            </a:r>
-          </a:p>
         </p:txBody>
       </p:sp>
       <p:sp>
@@ -4065,77 +2245,7 @@
         <p:txBody>
           <a:bodyPr/>
           <a:lstStyle/>
-          <a:p>
-            <a:r>
-              <a:t>WHAT TO SAY:</a:t>
-            </a:r>
-          </a:p>
-          <a:p>
-            <a:r>
-              <a:t>Read with expression. Pause at mystery moments.</a:t>
-            </a:r>
-          </a:p>
           <a:p/>
-          <a:p>
-            <a:r>
-              <a:t>STUDENT ACTIVITY:</a:t>
-            </a:r>
-          </a:p>
-          <a:p>
-            <a:r>
-              <a:t>Listen first; then read 1 paragraph.</a:t>
-            </a:r>
-          </a:p>
-          <a:p/>
-          <a:p>
-            <a:r>
-              <a:t>EXPECTED ANSWERS / RESPONSES:</a:t>
-            </a:r>
-          </a:p>
-          <a:p>
-            <a:r>
-              <a:t>Follows plot; asks about unknown words.</a:t>
-            </a:r>
-          </a:p>
-          <a:p/>
-          <a:p>
-            <a:r>
-              <a:t>COMMON MISTAKES:</a:t>
-            </a:r>
-          </a:p>
-          <a:p>
-            <a:r>
-              <a:t>Losing place in text.</a:t>
-            </a:r>
-          </a:p>
-          <a:p/>
-          <a:p>
-            <a:r>
-              <a:t>ASSESSMENT TIPS:</a:t>
-            </a:r>
-          </a:p>
-          <a:p>
-            <a:r>
-              <a:t>Decoding, fluency, engagement.</a:t>
-            </a:r>
-          </a:p>
-          <a:p/>
-          <a:p>
-            <a:r>
-              <a:t>EXTENSION QUESTIONS:</a:t>
-            </a:r>
-          </a:p>
-          <a:p>
-            <a:r>
-              <a:t>Predict: Where is the backpack?</a:t>
-            </a:r>
-          </a:p>
-          <a:p/>
-          <a:p>
-            <a:r>
-              <a:t>TIMING: Reading block ~8 min</a:t>
-            </a:r>
-          </a:p>
         </p:txBody>
       </p:sp>
       <p:sp>
@@ -4201,77 +2311,7 @@
         <p:txBody>
           <a:bodyPr/>
           <a:lstStyle/>
-          <a:p>
-            <a:r>
-              <a:t>WHAT TO SAY:</a:t>
-            </a:r>
-          </a:p>
-          <a:p>
-            <a:r>
-              <a:t>Clap syllables; choral repeat.</a:t>
-            </a:r>
-          </a:p>
           <a:p/>
-          <a:p>
-            <a:r>
-              <a:t>STUDENT ACTIVITY:</a:t>
-            </a:r>
-          </a:p>
-          <a:p>
-            <a:r>
-              <a:t>Repeat each word; one sentence each.</a:t>
-            </a:r>
-          </a:p>
-          <a:p/>
-          <a:p>
-            <a:r>
-              <a:t>EXPECTED ANSWERS / RESPONSES:</a:t>
-            </a:r>
-          </a:p>
-          <a:p>
-            <a:r>
-              <a:t>Approximate American pronunciation.</a:t>
-            </a:r>
-          </a:p>
-          <a:p/>
-          <a:p>
-            <a:r>
-              <a:t>COMMON MISTAKES:</a:t>
-            </a:r>
-          </a:p>
-          <a:p>
-            <a:r>
-              <a:t>Stress on wrong syllable.</a:t>
-            </a:r>
-          </a:p>
-          <a:p/>
-          <a:p>
-            <a:r>
-              <a:t>ASSESSMENT TIPS:</a:t>
-            </a:r>
-          </a:p>
-          <a:p>
-            <a:r>
-              <a:t>Pronunciation + usage.</a:t>
-            </a:r>
-          </a:p>
-          <a:p/>
-          <a:p>
-            <a:r>
-              <a:t>EXTENSION QUESTIONS:</a:t>
-            </a:r>
-          </a:p>
-          <a:p>
-            <a:r>
-              <a:t>Use 'observation' about the story.</a:t>
-            </a:r>
-          </a:p>
-          <a:p/>
-          <a:p>
-            <a:r>
-              <a:t>TIMING: Reading 20 min block</a:t>
-            </a:r>
-          </a:p>
         </p:txBody>
       </p:sp>
       <p:sp>
@@ -4337,77 +2377,7 @@
         <p:txBody>
           <a:bodyPr/>
           <a:lstStyle/>
-          <a:p>
-            <a:r>
-              <a:t>WHAT TO SAY:</a:t>
-            </a:r>
-          </a:p>
-          <a:p>
-            <a:r>
-              <a:t>One question at a time; praise text evidence.</a:t>
-            </a:r>
-          </a:p>
           <a:p/>
-          <a:p>
-            <a:r>
-              <a:t>STUDENT ACTIVITY:</a:t>
-            </a:r>
-          </a:p>
-          <a:p>
-            <a:r>
-              <a:t>Answer all 10 (or 6 if time tight).</a:t>
-            </a:r>
-          </a:p>
-          <a:p/>
-          <a:p>
-            <a:r>
-              <a:t>EXPECTED ANSWERS / RESPONSES:</a:t>
-            </a:r>
-          </a:p>
-          <a:p>
-            <a:r>
-              <a:t>1A 2B 3T 4F 5 notebook/pencil case/slip 6 reading nook 7 solved mystery/habit 8 yes+reason 9B 10 locker→nook→note</a:t>
-            </a:r>
-          </a:p>
-          <a:p/>
-          <a:p>
-            <a:r>
-              <a:t>COMMON MISTAKES:</a:t>
-            </a:r>
-          </a:p>
-          <a:p>
-            <a:r>
-              <a:t>Guessing without story.</a:t>
-            </a:r>
-          </a:p>
-          <a:p/>
-          <a:p>
-            <a:r>
-              <a:t>ASSESSMENT TIPS:</a:t>
-            </a:r>
-          </a:p>
-          <a:p>
-            <a:r>
-              <a:t>Literal, inferential, opinion skills.</a:t>
-            </a:r>
-          </a:p>
-          <a:p/>
-          <a:p>
-            <a:r>
-              <a:t>EXTENSION QUESTIONS:</a:t>
-            </a:r>
-          </a:p>
-          <a:p>
-            <a:r>
-              <a:t>Which sentence proves your answer?</a:t>
-            </a:r>
-          </a:p>
-          <a:p/>
-          <a:p>
-            <a:r>
-              <a:t>TIMING: Reading 20 min</a:t>
-            </a:r>
-          </a:p>
         </p:txBody>
       </p:sp>
       <p:sp>
@@ -4473,77 +2443,7 @@
         <p:txBody>
           <a:bodyPr/>
           <a:lstStyle/>
-          <a:p>
-            <a:r>
-              <a:t>WHAT TO SAY:</a:t>
-            </a:r>
-          </a:p>
-          <a:p>
-            <a:r>
-              <a:t>Student retells without reading slide.</a:t>
-            </a:r>
-          </a:p>
           <a:p/>
-          <a:p>
-            <a:r>
-              <a:t>STUDENT ACTIVITY:</a:t>
-            </a:r>
-          </a:p>
-          <a:p>
-            <a:r>
-              <a:t>60–90 second story retell using prompts.</a:t>
-            </a:r>
-          </a:p>
-          <a:p/>
-          <a:p>
-            <a:r>
-              <a:t>EXPECTED ANSWERS / RESPONSES:</a:t>
-            </a:r>
-          </a:p>
-          <a:p>
-            <a:r>
-              <a:t>Clear beginning/middle/end; past tense.</a:t>
-            </a:r>
-          </a:p>
-          <a:p/>
-          <a:p>
-            <a:r>
-              <a:t>COMMON MISTAKES:</a:t>
-            </a:r>
-          </a:p>
-          <a:p>
-            <a:r>
-              <a:t>Copying exact sentences.</a:t>
-            </a:r>
-          </a:p>
-          <a:p/>
-          <a:p>
-            <a:r>
-              <a:t>ASSESSMENT TIPS:</a:t>
-            </a:r>
-          </a:p>
-          <a:p>
-            <a:r>
-              <a:t>Oral organization, confidence.</a:t>
-            </a:r>
-          </a:p>
-          <a:p/>
-          <a:p>
-            <a:r>
-              <a:t>EXTENSION QUESTIONS:</a:t>
-            </a:r>
-          </a:p>
-          <a:p>
-            <a:r>
-              <a:t>Add how Leo felt at each step.</a:t>
-            </a:r>
-          </a:p>
-          <a:p/>
-          <a:p>
-            <a:r>
-              <a:t>TIMING: Speaking 10 min</a:t>
-            </a:r>
-          </a:p>
         </p:txBody>
       </p:sp>
       <p:sp>

</xml_diff>

<commit_message>
Fix overlapping text on grid slides in premium Sage demo PPT.
Co-authored-by: Cursor <cursoragent@cursor.com>
</commit_message>
<xml_diff>
--- a/Grade5_Sage_Premium_English_Demo_90min.pptx
+++ b/Grade5_Sage_Premium_English_Demo_90min.pptx
@@ -6,35 +6,35 @@
   </p:sldMasterIdLst>
   <p:sldIdLst>
     <p:sldId id="256" r:id="rId7"/>
-    <p:sldId id="257" r:id="rId9"/>
-    <p:sldId id="258" r:id="rId10"/>
-    <p:sldId id="259" r:id="rId11"/>
-    <p:sldId id="260" r:id="rId12"/>
-    <p:sldId id="261" r:id="rId13"/>
-    <p:sldId id="262" r:id="rId14"/>
-    <p:sldId id="263" r:id="rId15"/>
-    <p:sldId id="264" r:id="rId16"/>
-    <p:sldId id="265" r:id="rId17"/>
-    <p:sldId id="266" r:id="rId18"/>
-    <p:sldId id="267" r:id="rId19"/>
-    <p:sldId id="268" r:id="rId20"/>
-    <p:sldId id="269" r:id="rId21"/>
-    <p:sldId id="270" r:id="rId22"/>
-    <p:sldId id="271" r:id="rId23"/>
-    <p:sldId id="272" r:id="rId24"/>
-    <p:sldId id="273" r:id="rId25"/>
-    <p:sldId id="274" r:id="rId26"/>
-    <p:sldId id="275" r:id="rId27"/>
-    <p:sldId id="276" r:id="rId28"/>
-    <p:sldId id="277" r:id="rId29"/>
-    <p:sldId id="278" r:id="rId30"/>
-    <p:sldId id="279" r:id="rId31"/>
-    <p:sldId id="280" r:id="rId32"/>
-    <p:sldId id="281" r:id="rId33"/>
-    <p:sldId id="282" r:id="rId34"/>
-    <p:sldId id="283" r:id="rId35"/>
-    <p:sldId id="284" r:id="rId36"/>
-    <p:sldId id="285" r:id="rId37"/>
+    <p:sldId id="257" r:id="rId8"/>
+    <p:sldId id="258" r:id="rId9"/>
+    <p:sldId id="259" r:id="rId10"/>
+    <p:sldId id="260" r:id="rId11"/>
+    <p:sldId id="261" r:id="rId12"/>
+    <p:sldId id="262" r:id="rId13"/>
+    <p:sldId id="263" r:id="rId14"/>
+    <p:sldId id="264" r:id="rId15"/>
+    <p:sldId id="265" r:id="rId16"/>
+    <p:sldId id="266" r:id="rId17"/>
+    <p:sldId id="267" r:id="rId18"/>
+    <p:sldId id="268" r:id="rId19"/>
+    <p:sldId id="269" r:id="rId20"/>
+    <p:sldId id="270" r:id="rId21"/>
+    <p:sldId id="271" r:id="rId22"/>
+    <p:sldId id="272" r:id="rId23"/>
+    <p:sldId id="273" r:id="rId24"/>
+    <p:sldId id="274" r:id="rId25"/>
+    <p:sldId id="275" r:id="rId26"/>
+    <p:sldId id="276" r:id="rId27"/>
+    <p:sldId id="277" r:id="rId28"/>
+    <p:sldId id="278" r:id="rId29"/>
+    <p:sldId id="279" r:id="rId30"/>
+    <p:sldId id="280" r:id="rId31"/>
+    <p:sldId id="281" r:id="rId32"/>
+    <p:sldId id="282" r:id="rId33"/>
+    <p:sldId id="283" r:id="rId34"/>
+    <p:sldId id="284" r:id="rId35"/>
+    <p:sldId id="285" r:id="rId36"/>
   </p:sldIdLst>
   <p:sldSz cx="12191695" cy="6858000" type="screen4x3"/>
   <p:notesSz cx="6858000" cy="9144000"/>
@@ -136,2336 +136,6 @@
 </p:presentation>
 </file>
 
-<file path=ppt/notesMasters/notesMaster1.xml><?xml version="1.0" encoding="utf-8"?>
-<p:notesMaster xmlns:a="http://schemas.openxmlformats.org/drawingml/2006/main" xmlns:p="http://schemas.openxmlformats.org/presentationml/2006/main" xmlns:r="http://schemas.openxmlformats.org/officeDocument/2006/relationships">
-  <p:cSld>
-    <p:bg>
-      <p:bgRef idx="1001">
-        <a:schemeClr val="bg1"/>
-      </p:bgRef>
-    </p:bg>
-    <p:spTree>
-      <p:nvGrpSpPr>
-        <p:cNvPr id="1" name=""/>
-        <p:cNvGrpSpPr/>
-        <p:nvPr/>
-      </p:nvGrpSpPr>
-      <p:grpSpPr>
-        <a:xfrm>
-          <a:off x="0" y="0"/>
-          <a:ext cx="0" cy="0"/>
-          <a:chOff x="0" y="0"/>
-          <a:chExt cx="0" cy="0"/>
-        </a:xfrm>
-      </p:grpSpPr>
-      <p:sp>
-        <p:nvSpPr>
-          <p:cNvPr id="2" name="Header Placeholder 1"/>
-          <p:cNvSpPr>
-            <a:spLocks noGrp="1"/>
-          </p:cNvSpPr>
-          <p:nvPr>
-            <p:ph type="hdr" sz="quarter"/>
-          </p:nvPr>
-        </p:nvSpPr>
-        <p:spPr>
-          <a:xfrm>
-            <a:off x="0" y="0"/>
-            <a:ext cx="2971800" cy="457200"/>
-          </a:xfrm>
-          <a:prstGeom prst="rect">
-            <a:avLst/>
-          </a:prstGeom>
-        </p:spPr>
-        <p:txBody>
-          <a:bodyPr vert="horz" lIns="91440" tIns="45720" rIns="91440" bIns="45720" rtlCol="0"/>
-          <a:lstStyle>
-            <a:lvl1pPr algn="l">
-              <a:defRPr sz="1200"/>
-            </a:lvl1pPr>
-          </a:lstStyle>
-          <a:p>
-            <a:endParaRPr lang="en-US"/>
-          </a:p>
-        </p:txBody>
-      </p:sp>
-      <p:sp>
-        <p:nvSpPr>
-          <p:cNvPr id="3" name="Date Placeholder 2"/>
-          <p:cNvSpPr>
-            <a:spLocks noGrp="1"/>
-          </p:cNvSpPr>
-          <p:nvPr>
-            <p:ph type="dt" idx="1"/>
-          </p:nvPr>
-        </p:nvSpPr>
-        <p:spPr>
-          <a:xfrm>
-            <a:off x="3884613" y="0"/>
-            <a:ext cx="2971800" cy="457200"/>
-          </a:xfrm>
-          <a:prstGeom prst="rect">
-            <a:avLst/>
-          </a:prstGeom>
-        </p:spPr>
-        <p:txBody>
-          <a:bodyPr vert="horz" lIns="91440" tIns="45720" rIns="91440" bIns="45720" rtlCol="0"/>
-          <a:lstStyle>
-            <a:lvl1pPr algn="r">
-              <a:defRPr sz="1200"/>
-            </a:lvl1pPr>
-          </a:lstStyle>
-          <a:p>
-            <a:fld id="{0F89C1C7-3DCD-1040-A9CF-14679D8B5DDD}" type="datetimeFigureOut">
-              <a:rPr lang="en-US" smtClean="0"/>
-              <a:t>10/17/16</a:t>
-            </a:fld>
-            <a:endParaRPr lang="en-US"/>
-          </a:p>
-        </p:txBody>
-      </p:sp>
-      <p:sp>
-        <p:nvSpPr>
-          <p:cNvPr id="4" name="Slide Image Placeholder 3"/>
-          <p:cNvSpPr>
-            <a:spLocks noGrp="1" noRot="1" noChangeAspect="1"/>
-          </p:cNvSpPr>
-          <p:nvPr>
-            <p:ph type="sldImg" idx="2"/>
-          </p:nvPr>
-        </p:nvSpPr>
-        <p:spPr>
-          <a:xfrm>
-            <a:off x="1143000" y="685800"/>
-            <a:ext cx="4572000" cy="3429000"/>
-          </a:xfrm>
-          <a:prstGeom prst="rect">
-            <a:avLst/>
-          </a:prstGeom>
-          <a:noFill/>
-          <a:ln w="12700">
-            <a:solidFill>
-              <a:prstClr val="black"/>
-            </a:solidFill>
-          </a:ln>
-        </p:spPr>
-        <p:txBody>
-          <a:bodyPr vert="horz" lIns="91440" tIns="45720" rIns="91440" bIns="45720" rtlCol="0" anchor="ctr"/>
-          <a:lstStyle/>
-          <a:p>
-            <a:endParaRPr lang="en-US"/>
-          </a:p>
-        </p:txBody>
-      </p:sp>
-      <p:sp>
-        <p:nvSpPr>
-          <p:cNvPr id="5" name="Notes Placeholder 4"/>
-          <p:cNvSpPr>
-            <a:spLocks noGrp="1"/>
-          </p:cNvSpPr>
-          <p:nvPr>
-            <p:ph type="body" sz="quarter" idx="3"/>
-          </p:nvPr>
-        </p:nvSpPr>
-        <p:spPr>
-          <a:xfrm>
-            <a:off x="685800" y="4343400"/>
-            <a:ext cx="5486400" cy="4114800"/>
-          </a:xfrm>
-          <a:prstGeom prst="rect">
-            <a:avLst/>
-          </a:prstGeom>
-        </p:spPr>
-        <p:txBody>
-          <a:bodyPr vert="horz" lIns="91440" tIns="45720" rIns="91440" bIns="45720" rtlCol="0"/>
-          <a:lstStyle/>
-          <a:p>
-            <a:pPr lvl="0"/>
-            <a:r>
-              <a:rPr lang="en-US" smtClean="0"/>
-              <a:t>Click to edit Master text styles</a:t>
-            </a:r>
-          </a:p>
-          <a:p>
-            <a:pPr lvl="1"/>
-            <a:r>
-              <a:rPr lang="en-US" smtClean="0"/>
-              <a:t>Second level</a:t>
-            </a:r>
-          </a:p>
-          <a:p>
-            <a:pPr lvl="2"/>
-            <a:r>
-              <a:rPr lang="en-US" smtClean="0"/>
-              <a:t>Third level</a:t>
-            </a:r>
-          </a:p>
-          <a:p>
-            <a:pPr lvl="3"/>
-            <a:r>
-              <a:rPr lang="en-US" smtClean="0"/>
-              <a:t>Fourth level</a:t>
-            </a:r>
-          </a:p>
-          <a:p>
-            <a:pPr lvl="4"/>
-            <a:r>
-              <a:rPr lang="en-US" smtClean="0"/>
-              <a:t>Fifth level</a:t>
-            </a:r>
-            <a:endParaRPr lang="en-US"/>
-          </a:p>
-        </p:txBody>
-      </p:sp>
-      <p:sp>
-        <p:nvSpPr>
-          <p:cNvPr id="6" name="Footer Placeholder 5"/>
-          <p:cNvSpPr>
-            <a:spLocks noGrp="1"/>
-          </p:cNvSpPr>
-          <p:nvPr>
-            <p:ph type="ftr" sz="quarter" idx="4"/>
-          </p:nvPr>
-        </p:nvSpPr>
-        <p:spPr>
-          <a:xfrm>
-            <a:off x="0" y="8685213"/>
-            <a:ext cx="2971800" cy="457200"/>
-          </a:xfrm>
-          <a:prstGeom prst="rect">
-            <a:avLst/>
-          </a:prstGeom>
-        </p:spPr>
-        <p:txBody>
-          <a:bodyPr vert="horz" lIns="91440" tIns="45720" rIns="91440" bIns="45720" rtlCol="0" anchor="b"/>
-          <a:lstStyle>
-            <a:lvl1pPr algn="l">
-              <a:defRPr sz="1200"/>
-            </a:lvl1pPr>
-          </a:lstStyle>
-          <a:p>
-            <a:endParaRPr lang="en-US"/>
-          </a:p>
-        </p:txBody>
-      </p:sp>
-      <p:sp>
-        <p:nvSpPr>
-          <p:cNvPr id="7" name="Slide Number Placeholder 6"/>
-          <p:cNvSpPr>
-            <a:spLocks noGrp="1"/>
-          </p:cNvSpPr>
-          <p:nvPr>
-            <p:ph type="sldNum" sz="quarter" idx="5"/>
-          </p:nvPr>
-        </p:nvSpPr>
-        <p:spPr>
-          <a:xfrm>
-            <a:off x="3884613" y="8685213"/>
-            <a:ext cx="2971800" cy="457200"/>
-          </a:xfrm>
-          <a:prstGeom prst="rect">
-            <a:avLst/>
-          </a:prstGeom>
-        </p:spPr>
-        <p:txBody>
-          <a:bodyPr vert="horz" lIns="91440" tIns="45720" rIns="91440" bIns="45720" rtlCol="0" anchor="b"/>
-          <a:lstStyle>
-            <a:lvl1pPr algn="r">
-              <a:defRPr sz="1200"/>
-            </a:lvl1pPr>
-          </a:lstStyle>
-          <a:p>
-            <a:fld id="{BB5E49A5-4136-284D-997B-48E1D791AD67}" type="slidenum">
-              <a:rPr lang="en-US" smtClean="0"/>
-              <a:t>‹#›</a:t>
-            </a:fld>
-            <a:endParaRPr lang="en-US"/>
-          </a:p>
-        </p:txBody>
-      </p:sp>
-    </p:spTree>
-    <p:extLst>
-      <p:ext uri="{BB962C8B-B14F-4D97-AF65-F5344CB8AC3E}">
-        <p14:creationId xmlns:p14="http://schemas.microsoft.com/office/powerpoint/2010/main" val="2623252185"/>
-      </p:ext>
-    </p:extLst>
-  </p:cSld>
-  <p:clrMap bg1="lt1" tx1="dk1" bg2="lt2" tx2="dk2" accent1="accent1" accent2="accent2" accent3="accent3" accent4="accent4" accent5="accent5" accent6="accent6" hlink="hlink" folHlink="folHlink"/>
-  <p:notesStyle>
-    <a:lvl1pPr marL="0" algn="l" defTabSz="457200" rtl="0" eaLnBrk="1" latinLnBrk="0" hangingPunct="1">
-      <a:defRPr sz="1200" kern="1200">
-        <a:solidFill>
-          <a:schemeClr val="tx1"/>
-        </a:solidFill>
-        <a:latin typeface="+mn-lt"/>
-        <a:ea typeface="+mn-ea"/>
-        <a:cs typeface="+mn-cs"/>
-      </a:defRPr>
-    </a:lvl1pPr>
-    <a:lvl2pPr marL="457200" algn="l" defTabSz="457200" rtl="0" eaLnBrk="1" latinLnBrk="0" hangingPunct="1">
-      <a:defRPr sz="1200" kern="1200">
-        <a:solidFill>
-          <a:schemeClr val="tx1"/>
-        </a:solidFill>
-        <a:latin typeface="+mn-lt"/>
-        <a:ea typeface="+mn-ea"/>
-        <a:cs typeface="+mn-cs"/>
-      </a:defRPr>
-    </a:lvl2pPr>
-    <a:lvl3pPr marL="914400" algn="l" defTabSz="457200" rtl="0" eaLnBrk="1" latinLnBrk="0" hangingPunct="1">
-      <a:defRPr sz="1200" kern="1200">
-        <a:solidFill>
-          <a:schemeClr val="tx1"/>
-        </a:solidFill>
-        <a:latin typeface="+mn-lt"/>
-        <a:ea typeface="+mn-ea"/>
-        <a:cs typeface="+mn-cs"/>
-      </a:defRPr>
-    </a:lvl3pPr>
-    <a:lvl4pPr marL="1371600" algn="l" defTabSz="457200" rtl="0" eaLnBrk="1" latinLnBrk="0" hangingPunct="1">
-      <a:defRPr sz="1200" kern="1200">
-        <a:solidFill>
-          <a:schemeClr val="tx1"/>
-        </a:solidFill>
-        <a:latin typeface="+mn-lt"/>
-        <a:ea typeface="+mn-ea"/>
-        <a:cs typeface="+mn-cs"/>
-      </a:defRPr>
-    </a:lvl4pPr>
-    <a:lvl5pPr marL="1828800" algn="l" defTabSz="457200" rtl="0" eaLnBrk="1" latinLnBrk="0" hangingPunct="1">
-      <a:defRPr sz="1200" kern="1200">
-        <a:solidFill>
-          <a:schemeClr val="tx1"/>
-        </a:solidFill>
-        <a:latin typeface="+mn-lt"/>
-        <a:ea typeface="+mn-ea"/>
-        <a:cs typeface="+mn-cs"/>
-      </a:defRPr>
-    </a:lvl5pPr>
-    <a:lvl6pPr marL="2286000" algn="l" defTabSz="457200" rtl="0" eaLnBrk="1" latinLnBrk="0" hangingPunct="1">
-      <a:defRPr sz="1200" kern="1200">
-        <a:solidFill>
-          <a:schemeClr val="tx1"/>
-        </a:solidFill>
-        <a:latin typeface="+mn-lt"/>
-        <a:ea typeface="+mn-ea"/>
-        <a:cs typeface="+mn-cs"/>
-      </a:defRPr>
-    </a:lvl6pPr>
-    <a:lvl7pPr marL="2743200" algn="l" defTabSz="457200" rtl="0" eaLnBrk="1" latinLnBrk="0" hangingPunct="1">
-      <a:defRPr sz="1200" kern="1200">
-        <a:solidFill>
-          <a:schemeClr val="tx1"/>
-        </a:solidFill>
-        <a:latin typeface="+mn-lt"/>
-        <a:ea typeface="+mn-ea"/>
-        <a:cs typeface="+mn-cs"/>
-      </a:defRPr>
-    </a:lvl7pPr>
-    <a:lvl8pPr marL="3200400" algn="l" defTabSz="457200" rtl="0" eaLnBrk="1" latinLnBrk="0" hangingPunct="1">
-      <a:defRPr sz="1200" kern="1200">
-        <a:solidFill>
-          <a:schemeClr val="tx1"/>
-        </a:solidFill>
-        <a:latin typeface="+mn-lt"/>
-        <a:ea typeface="+mn-ea"/>
-        <a:cs typeface="+mn-cs"/>
-      </a:defRPr>
-    </a:lvl8pPr>
-    <a:lvl9pPr marL="3657600" algn="l" defTabSz="457200" rtl="0" eaLnBrk="1" latinLnBrk="0" hangingPunct="1">
-      <a:defRPr sz="1200" kern="1200">
-        <a:solidFill>
-          <a:schemeClr val="tx1"/>
-        </a:solidFill>
-        <a:latin typeface="+mn-lt"/>
-        <a:ea typeface="+mn-ea"/>
-        <a:cs typeface="+mn-cs"/>
-      </a:defRPr>
-    </a:lvl9pPr>
-  </p:notesStyle>
-</p:notesMaster>
-</file>
-
-<file path=ppt/notesSlides/notesSlide1.xml><?xml version="1.0" encoding="utf-8"?>
-<p:notes xmlns:a="http://schemas.openxmlformats.org/drawingml/2006/main" xmlns:p="http://schemas.openxmlformats.org/presentationml/2006/main" xmlns:r="http://schemas.openxmlformats.org/officeDocument/2006/relationships">
-  <p:cSld>
-    <p:spTree>
-      <p:nvGrpSpPr>
-        <p:cNvPr id="1" name=""/>
-        <p:cNvGrpSpPr/>
-        <p:nvPr/>
-      </p:nvGrpSpPr>
-      <p:grpSpPr>
-        <a:xfrm>
-          <a:off x="0" y="0"/>
-          <a:ext cx="0" cy="0"/>
-          <a:chOff x="0" y="0"/>
-          <a:chExt cx="0" cy="0"/>
-        </a:xfrm>
-      </p:grpSpPr>
-      <p:sp>
-        <p:nvSpPr>
-          <p:cNvPr id="2" name="Slide Image Placeholder 1"/>
-          <p:cNvSpPr>
-            <a:spLocks noGrp="1"/>
-          </p:cNvSpPr>
-          <p:nvPr>
-            <p:ph type="sldImg" idx="2"/>
-          </p:nvPr>
-        </p:nvSpPr>
-        <p:spPr/>
-      </p:sp>
-      <p:sp>
-        <p:nvSpPr>
-          <p:cNvPr id="3" name="Notes Placeholder 2"/>
-          <p:cNvSpPr>
-            <a:spLocks noGrp="1"/>
-          </p:cNvSpPr>
-          <p:nvPr>
-            <p:ph type="body" idx="3" sz="quarter"/>
-          </p:nvPr>
-        </p:nvSpPr>
-        <p:spPr/>
-        <p:txBody>
-          <a:bodyPr/>
-          <a:lstStyle/>
-          <a:p/>
-        </p:txBody>
-      </p:sp>
-      <p:sp>
-        <p:nvSpPr>
-          <p:cNvPr id="4" name="Slide Number Placeholder 3"/>
-          <p:cNvSpPr>
-            <a:spLocks noGrp="1"/>
-          </p:cNvSpPr>
-          <p:nvPr>
-            <p:ph type="sldNum" idx="5" sz="quarter"/>
-          </p:nvPr>
-        </p:nvSpPr>
-        <p:spPr/>
-      </p:sp>
-    </p:spTree>
-  </p:cSld>
-  <p:clrMapOvr>
-    <a:masterClrMapping/>
-  </p:clrMapOvr>
-</p:notes>
-</file>
-
-<file path=ppt/notesSlides/notesSlide10.xml><?xml version="1.0" encoding="utf-8"?>
-<p:notes xmlns:a="http://schemas.openxmlformats.org/drawingml/2006/main" xmlns:p="http://schemas.openxmlformats.org/presentationml/2006/main" xmlns:r="http://schemas.openxmlformats.org/officeDocument/2006/relationships">
-  <p:cSld>
-    <p:spTree>
-      <p:nvGrpSpPr>
-        <p:cNvPr id="1" name=""/>
-        <p:cNvGrpSpPr/>
-        <p:nvPr/>
-      </p:nvGrpSpPr>
-      <p:grpSpPr>
-        <a:xfrm>
-          <a:off x="0" y="0"/>
-          <a:ext cx="0" cy="0"/>
-          <a:chOff x="0" y="0"/>
-          <a:chExt cx="0" cy="0"/>
-        </a:xfrm>
-      </p:grpSpPr>
-      <p:sp>
-        <p:nvSpPr>
-          <p:cNvPr id="2" name="Slide Image Placeholder 1"/>
-          <p:cNvSpPr>
-            <a:spLocks noGrp="1"/>
-          </p:cNvSpPr>
-          <p:nvPr>
-            <p:ph type="sldImg" idx="2"/>
-          </p:nvPr>
-        </p:nvSpPr>
-        <p:spPr/>
-      </p:sp>
-      <p:sp>
-        <p:nvSpPr>
-          <p:cNvPr id="3" name="Notes Placeholder 2"/>
-          <p:cNvSpPr>
-            <a:spLocks noGrp="1"/>
-          </p:cNvSpPr>
-          <p:nvPr>
-            <p:ph type="body" idx="3" sz="quarter"/>
-          </p:nvPr>
-        </p:nvSpPr>
-        <p:spPr/>
-        <p:txBody>
-          <a:bodyPr/>
-          <a:lstStyle/>
-          <a:p/>
-        </p:txBody>
-      </p:sp>
-      <p:sp>
-        <p:nvSpPr>
-          <p:cNvPr id="4" name="Slide Number Placeholder 3"/>
-          <p:cNvSpPr>
-            <a:spLocks noGrp="1"/>
-          </p:cNvSpPr>
-          <p:nvPr>
-            <p:ph type="sldNum" idx="5" sz="quarter"/>
-          </p:nvPr>
-        </p:nvSpPr>
-        <p:spPr/>
-      </p:sp>
-    </p:spTree>
-  </p:cSld>
-  <p:clrMapOvr>
-    <a:masterClrMapping/>
-  </p:clrMapOvr>
-</p:notes>
-</file>
-
-<file path=ppt/notesSlides/notesSlide11.xml><?xml version="1.0" encoding="utf-8"?>
-<p:notes xmlns:a="http://schemas.openxmlformats.org/drawingml/2006/main" xmlns:p="http://schemas.openxmlformats.org/presentationml/2006/main" xmlns:r="http://schemas.openxmlformats.org/officeDocument/2006/relationships">
-  <p:cSld>
-    <p:spTree>
-      <p:nvGrpSpPr>
-        <p:cNvPr id="1" name=""/>
-        <p:cNvGrpSpPr/>
-        <p:nvPr/>
-      </p:nvGrpSpPr>
-      <p:grpSpPr>
-        <a:xfrm>
-          <a:off x="0" y="0"/>
-          <a:ext cx="0" cy="0"/>
-          <a:chOff x="0" y="0"/>
-          <a:chExt cx="0" cy="0"/>
-        </a:xfrm>
-      </p:grpSpPr>
-      <p:sp>
-        <p:nvSpPr>
-          <p:cNvPr id="2" name="Slide Image Placeholder 1"/>
-          <p:cNvSpPr>
-            <a:spLocks noGrp="1"/>
-          </p:cNvSpPr>
-          <p:nvPr>
-            <p:ph type="sldImg" idx="2"/>
-          </p:nvPr>
-        </p:nvSpPr>
-        <p:spPr/>
-      </p:sp>
-      <p:sp>
-        <p:nvSpPr>
-          <p:cNvPr id="3" name="Notes Placeholder 2"/>
-          <p:cNvSpPr>
-            <a:spLocks noGrp="1"/>
-          </p:cNvSpPr>
-          <p:nvPr>
-            <p:ph type="body" idx="3" sz="quarter"/>
-          </p:nvPr>
-        </p:nvSpPr>
-        <p:spPr/>
-        <p:txBody>
-          <a:bodyPr/>
-          <a:lstStyle/>
-          <a:p/>
-        </p:txBody>
-      </p:sp>
-      <p:sp>
-        <p:nvSpPr>
-          <p:cNvPr id="4" name="Slide Number Placeholder 3"/>
-          <p:cNvSpPr>
-            <a:spLocks noGrp="1"/>
-          </p:cNvSpPr>
-          <p:nvPr>
-            <p:ph type="sldNum" idx="5" sz="quarter"/>
-          </p:nvPr>
-        </p:nvSpPr>
-        <p:spPr/>
-      </p:sp>
-    </p:spTree>
-  </p:cSld>
-  <p:clrMapOvr>
-    <a:masterClrMapping/>
-  </p:clrMapOvr>
-</p:notes>
-</file>
-
-<file path=ppt/notesSlides/notesSlide12.xml><?xml version="1.0" encoding="utf-8"?>
-<p:notes xmlns:a="http://schemas.openxmlformats.org/drawingml/2006/main" xmlns:p="http://schemas.openxmlformats.org/presentationml/2006/main" xmlns:r="http://schemas.openxmlformats.org/officeDocument/2006/relationships">
-  <p:cSld>
-    <p:spTree>
-      <p:nvGrpSpPr>
-        <p:cNvPr id="1" name=""/>
-        <p:cNvGrpSpPr/>
-        <p:nvPr/>
-      </p:nvGrpSpPr>
-      <p:grpSpPr>
-        <a:xfrm>
-          <a:off x="0" y="0"/>
-          <a:ext cx="0" cy="0"/>
-          <a:chOff x="0" y="0"/>
-          <a:chExt cx="0" cy="0"/>
-        </a:xfrm>
-      </p:grpSpPr>
-      <p:sp>
-        <p:nvSpPr>
-          <p:cNvPr id="2" name="Slide Image Placeholder 1"/>
-          <p:cNvSpPr>
-            <a:spLocks noGrp="1"/>
-          </p:cNvSpPr>
-          <p:nvPr>
-            <p:ph type="sldImg" idx="2"/>
-          </p:nvPr>
-        </p:nvSpPr>
-        <p:spPr/>
-      </p:sp>
-      <p:sp>
-        <p:nvSpPr>
-          <p:cNvPr id="3" name="Notes Placeholder 2"/>
-          <p:cNvSpPr>
-            <a:spLocks noGrp="1"/>
-          </p:cNvSpPr>
-          <p:nvPr>
-            <p:ph type="body" idx="3" sz="quarter"/>
-          </p:nvPr>
-        </p:nvSpPr>
-        <p:spPr/>
-        <p:txBody>
-          <a:bodyPr/>
-          <a:lstStyle/>
-          <a:p/>
-        </p:txBody>
-      </p:sp>
-      <p:sp>
-        <p:nvSpPr>
-          <p:cNvPr id="4" name="Slide Number Placeholder 3"/>
-          <p:cNvSpPr>
-            <a:spLocks noGrp="1"/>
-          </p:cNvSpPr>
-          <p:nvPr>
-            <p:ph type="sldNum" idx="5" sz="quarter"/>
-          </p:nvPr>
-        </p:nvSpPr>
-        <p:spPr/>
-      </p:sp>
-    </p:spTree>
-  </p:cSld>
-  <p:clrMapOvr>
-    <a:masterClrMapping/>
-  </p:clrMapOvr>
-</p:notes>
-</file>
-
-<file path=ppt/notesSlides/notesSlide13.xml><?xml version="1.0" encoding="utf-8"?>
-<p:notes xmlns:a="http://schemas.openxmlformats.org/drawingml/2006/main" xmlns:p="http://schemas.openxmlformats.org/presentationml/2006/main" xmlns:r="http://schemas.openxmlformats.org/officeDocument/2006/relationships">
-  <p:cSld>
-    <p:spTree>
-      <p:nvGrpSpPr>
-        <p:cNvPr id="1" name=""/>
-        <p:cNvGrpSpPr/>
-        <p:nvPr/>
-      </p:nvGrpSpPr>
-      <p:grpSpPr>
-        <a:xfrm>
-          <a:off x="0" y="0"/>
-          <a:ext cx="0" cy="0"/>
-          <a:chOff x="0" y="0"/>
-          <a:chExt cx="0" cy="0"/>
-        </a:xfrm>
-      </p:grpSpPr>
-      <p:sp>
-        <p:nvSpPr>
-          <p:cNvPr id="2" name="Slide Image Placeholder 1"/>
-          <p:cNvSpPr>
-            <a:spLocks noGrp="1"/>
-          </p:cNvSpPr>
-          <p:nvPr>
-            <p:ph type="sldImg" idx="2"/>
-          </p:nvPr>
-        </p:nvSpPr>
-        <p:spPr/>
-      </p:sp>
-      <p:sp>
-        <p:nvSpPr>
-          <p:cNvPr id="3" name="Notes Placeholder 2"/>
-          <p:cNvSpPr>
-            <a:spLocks noGrp="1"/>
-          </p:cNvSpPr>
-          <p:nvPr>
-            <p:ph type="body" idx="3" sz="quarter"/>
-          </p:nvPr>
-        </p:nvSpPr>
-        <p:spPr/>
-        <p:txBody>
-          <a:bodyPr/>
-          <a:lstStyle/>
-          <a:p/>
-        </p:txBody>
-      </p:sp>
-      <p:sp>
-        <p:nvSpPr>
-          <p:cNvPr id="4" name="Slide Number Placeholder 3"/>
-          <p:cNvSpPr>
-            <a:spLocks noGrp="1"/>
-          </p:cNvSpPr>
-          <p:nvPr>
-            <p:ph type="sldNum" idx="5" sz="quarter"/>
-          </p:nvPr>
-        </p:nvSpPr>
-        <p:spPr/>
-      </p:sp>
-    </p:spTree>
-  </p:cSld>
-  <p:clrMapOvr>
-    <a:masterClrMapping/>
-  </p:clrMapOvr>
-</p:notes>
-</file>
-
-<file path=ppt/notesSlides/notesSlide14.xml><?xml version="1.0" encoding="utf-8"?>
-<p:notes xmlns:a="http://schemas.openxmlformats.org/drawingml/2006/main" xmlns:p="http://schemas.openxmlformats.org/presentationml/2006/main" xmlns:r="http://schemas.openxmlformats.org/officeDocument/2006/relationships">
-  <p:cSld>
-    <p:spTree>
-      <p:nvGrpSpPr>
-        <p:cNvPr id="1" name=""/>
-        <p:cNvGrpSpPr/>
-        <p:nvPr/>
-      </p:nvGrpSpPr>
-      <p:grpSpPr>
-        <a:xfrm>
-          <a:off x="0" y="0"/>
-          <a:ext cx="0" cy="0"/>
-          <a:chOff x="0" y="0"/>
-          <a:chExt cx="0" cy="0"/>
-        </a:xfrm>
-      </p:grpSpPr>
-      <p:sp>
-        <p:nvSpPr>
-          <p:cNvPr id="2" name="Slide Image Placeholder 1"/>
-          <p:cNvSpPr>
-            <a:spLocks noGrp="1"/>
-          </p:cNvSpPr>
-          <p:nvPr>
-            <p:ph type="sldImg" idx="2"/>
-          </p:nvPr>
-        </p:nvSpPr>
-        <p:spPr/>
-      </p:sp>
-      <p:sp>
-        <p:nvSpPr>
-          <p:cNvPr id="3" name="Notes Placeholder 2"/>
-          <p:cNvSpPr>
-            <a:spLocks noGrp="1"/>
-          </p:cNvSpPr>
-          <p:nvPr>
-            <p:ph type="body" idx="3" sz="quarter"/>
-          </p:nvPr>
-        </p:nvSpPr>
-        <p:spPr/>
-        <p:txBody>
-          <a:bodyPr/>
-          <a:lstStyle/>
-          <a:p/>
-        </p:txBody>
-      </p:sp>
-      <p:sp>
-        <p:nvSpPr>
-          <p:cNvPr id="4" name="Slide Number Placeholder 3"/>
-          <p:cNvSpPr>
-            <a:spLocks noGrp="1"/>
-          </p:cNvSpPr>
-          <p:nvPr>
-            <p:ph type="sldNum" idx="5" sz="quarter"/>
-          </p:nvPr>
-        </p:nvSpPr>
-        <p:spPr/>
-      </p:sp>
-    </p:spTree>
-  </p:cSld>
-  <p:clrMapOvr>
-    <a:masterClrMapping/>
-  </p:clrMapOvr>
-</p:notes>
-</file>
-
-<file path=ppt/notesSlides/notesSlide15.xml><?xml version="1.0" encoding="utf-8"?>
-<p:notes xmlns:a="http://schemas.openxmlformats.org/drawingml/2006/main" xmlns:p="http://schemas.openxmlformats.org/presentationml/2006/main" xmlns:r="http://schemas.openxmlformats.org/officeDocument/2006/relationships">
-  <p:cSld>
-    <p:spTree>
-      <p:nvGrpSpPr>
-        <p:cNvPr id="1" name=""/>
-        <p:cNvGrpSpPr/>
-        <p:nvPr/>
-      </p:nvGrpSpPr>
-      <p:grpSpPr>
-        <a:xfrm>
-          <a:off x="0" y="0"/>
-          <a:ext cx="0" cy="0"/>
-          <a:chOff x="0" y="0"/>
-          <a:chExt cx="0" cy="0"/>
-        </a:xfrm>
-      </p:grpSpPr>
-      <p:sp>
-        <p:nvSpPr>
-          <p:cNvPr id="2" name="Slide Image Placeholder 1"/>
-          <p:cNvSpPr>
-            <a:spLocks noGrp="1"/>
-          </p:cNvSpPr>
-          <p:nvPr>
-            <p:ph type="sldImg" idx="2"/>
-          </p:nvPr>
-        </p:nvSpPr>
-        <p:spPr/>
-      </p:sp>
-      <p:sp>
-        <p:nvSpPr>
-          <p:cNvPr id="3" name="Notes Placeholder 2"/>
-          <p:cNvSpPr>
-            <a:spLocks noGrp="1"/>
-          </p:cNvSpPr>
-          <p:nvPr>
-            <p:ph type="body" idx="3" sz="quarter"/>
-          </p:nvPr>
-        </p:nvSpPr>
-        <p:spPr/>
-        <p:txBody>
-          <a:bodyPr/>
-          <a:lstStyle/>
-          <a:p/>
-        </p:txBody>
-      </p:sp>
-      <p:sp>
-        <p:nvSpPr>
-          <p:cNvPr id="4" name="Slide Number Placeholder 3"/>
-          <p:cNvSpPr>
-            <a:spLocks noGrp="1"/>
-          </p:cNvSpPr>
-          <p:nvPr>
-            <p:ph type="sldNum" idx="5" sz="quarter"/>
-          </p:nvPr>
-        </p:nvSpPr>
-        <p:spPr/>
-      </p:sp>
-    </p:spTree>
-  </p:cSld>
-  <p:clrMapOvr>
-    <a:masterClrMapping/>
-  </p:clrMapOvr>
-</p:notes>
-</file>
-
-<file path=ppt/notesSlides/notesSlide16.xml><?xml version="1.0" encoding="utf-8"?>
-<p:notes xmlns:a="http://schemas.openxmlformats.org/drawingml/2006/main" xmlns:p="http://schemas.openxmlformats.org/presentationml/2006/main" xmlns:r="http://schemas.openxmlformats.org/officeDocument/2006/relationships">
-  <p:cSld>
-    <p:spTree>
-      <p:nvGrpSpPr>
-        <p:cNvPr id="1" name=""/>
-        <p:cNvGrpSpPr/>
-        <p:nvPr/>
-      </p:nvGrpSpPr>
-      <p:grpSpPr>
-        <a:xfrm>
-          <a:off x="0" y="0"/>
-          <a:ext cx="0" cy="0"/>
-          <a:chOff x="0" y="0"/>
-          <a:chExt cx="0" cy="0"/>
-        </a:xfrm>
-      </p:grpSpPr>
-      <p:sp>
-        <p:nvSpPr>
-          <p:cNvPr id="2" name="Slide Image Placeholder 1"/>
-          <p:cNvSpPr>
-            <a:spLocks noGrp="1"/>
-          </p:cNvSpPr>
-          <p:nvPr>
-            <p:ph type="sldImg" idx="2"/>
-          </p:nvPr>
-        </p:nvSpPr>
-        <p:spPr/>
-      </p:sp>
-      <p:sp>
-        <p:nvSpPr>
-          <p:cNvPr id="3" name="Notes Placeholder 2"/>
-          <p:cNvSpPr>
-            <a:spLocks noGrp="1"/>
-          </p:cNvSpPr>
-          <p:nvPr>
-            <p:ph type="body" idx="3" sz="quarter"/>
-          </p:nvPr>
-        </p:nvSpPr>
-        <p:spPr/>
-        <p:txBody>
-          <a:bodyPr/>
-          <a:lstStyle/>
-          <a:p/>
-        </p:txBody>
-      </p:sp>
-      <p:sp>
-        <p:nvSpPr>
-          <p:cNvPr id="4" name="Slide Number Placeholder 3"/>
-          <p:cNvSpPr>
-            <a:spLocks noGrp="1"/>
-          </p:cNvSpPr>
-          <p:nvPr>
-            <p:ph type="sldNum" idx="5" sz="quarter"/>
-          </p:nvPr>
-        </p:nvSpPr>
-        <p:spPr/>
-      </p:sp>
-    </p:spTree>
-  </p:cSld>
-  <p:clrMapOvr>
-    <a:masterClrMapping/>
-  </p:clrMapOvr>
-</p:notes>
-</file>
-
-<file path=ppt/notesSlides/notesSlide17.xml><?xml version="1.0" encoding="utf-8"?>
-<p:notes xmlns:a="http://schemas.openxmlformats.org/drawingml/2006/main" xmlns:p="http://schemas.openxmlformats.org/presentationml/2006/main" xmlns:r="http://schemas.openxmlformats.org/officeDocument/2006/relationships">
-  <p:cSld>
-    <p:spTree>
-      <p:nvGrpSpPr>
-        <p:cNvPr id="1" name=""/>
-        <p:cNvGrpSpPr/>
-        <p:nvPr/>
-      </p:nvGrpSpPr>
-      <p:grpSpPr>
-        <a:xfrm>
-          <a:off x="0" y="0"/>
-          <a:ext cx="0" cy="0"/>
-          <a:chOff x="0" y="0"/>
-          <a:chExt cx="0" cy="0"/>
-        </a:xfrm>
-      </p:grpSpPr>
-      <p:sp>
-        <p:nvSpPr>
-          <p:cNvPr id="2" name="Slide Image Placeholder 1"/>
-          <p:cNvSpPr>
-            <a:spLocks noGrp="1"/>
-          </p:cNvSpPr>
-          <p:nvPr>
-            <p:ph type="sldImg" idx="2"/>
-          </p:nvPr>
-        </p:nvSpPr>
-        <p:spPr/>
-      </p:sp>
-      <p:sp>
-        <p:nvSpPr>
-          <p:cNvPr id="3" name="Notes Placeholder 2"/>
-          <p:cNvSpPr>
-            <a:spLocks noGrp="1"/>
-          </p:cNvSpPr>
-          <p:nvPr>
-            <p:ph type="body" idx="3" sz="quarter"/>
-          </p:nvPr>
-        </p:nvSpPr>
-        <p:spPr/>
-        <p:txBody>
-          <a:bodyPr/>
-          <a:lstStyle/>
-          <a:p/>
-        </p:txBody>
-      </p:sp>
-      <p:sp>
-        <p:nvSpPr>
-          <p:cNvPr id="4" name="Slide Number Placeholder 3"/>
-          <p:cNvSpPr>
-            <a:spLocks noGrp="1"/>
-          </p:cNvSpPr>
-          <p:nvPr>
-            <p:ph type="sldNum" idx="5" sz="quarter"/>
-          </p:nvPr>
-        </p:nvSpPr>
-        <p:spPr/>
-      </p:sp>
-    </p:spTree>
-  </p:cSld>
-  <p:clrMapOvr>
-    <a:masterClrMapping/>
-  </p:clrMapOvr>
-</p:notes>
-</file>
-
-<file path=ppt/notesSlides/notesSlide18.xml><?xml version="1.0" encoding="utf-8"?>
-<p:notes xmlns:a="http://schemas.openxmlformats.org/drawingml/2006/main" xmlns:p="http://schemas.openxmlformats.org/presentationml/2006/main" xmlns:r="http://schemas.openxmlformats.org/officeDocument/2006/relationships">
-  <p:cSld>
-    <p:spTree>
-      <p:nvGrpSpPr>
-        <p:cNvPr id="1" name=""/>
-        <p:cNvGrpSpPr/>
-        <p:nvPr/>
-      </p:nvGrpSpPr>
-      <p:grpSpPr>
-        <a:xfrm>
-          <a:off x="0" y="0"/>
-          <a:ext cx="0" cy="0"/>
-          <a:chOff x="0" y="0"/>
-          <a:chExt cx="0" cy="0"/>
-        </a:xfrm>
-      </p:grpSpPr>
-      <p:sp>
-        <p:nvSpPr>
-          <p:cNvPr id="2" name="Slide Image Placeholder 1"/>
-          <p:cNvSpPr>
-            <a:spLocks noGrp="1"/>
-          </p:cNvSpPr>
-          <p:nvPr>
-            <p:ph type="sldImg" idx="2"/>
-          </p:nvPr>
-        </p:nvSpPr>
-        <p:spPr/>
-      </p:sp>
-      <p:sp>
-        <p:nvSpPr>
-          <p:cNvPr id="3" name="Notes Placeholder 2"/>
-          <p:cNvSpPr>
-            <a:spLocks noGrp="1"/>
-          </p:cNvSpPr>
-          <p:nvPr>
-            <p:ph type="body" idx="3" sz="quarter"/>
-          </p:nvPr>
-        </p:nvSpPr>
-        <p:spPr/>
-        <p:txBody>
-          <a:bodyPr/>
-          <a:lstStyle/>
-          <a:p/>
-        </p:txBody>
-      </p:sp>
-      <p:sp>
-        <p:nvSpPr>
-          <p:cNvPr id="4" name="Slide Number Placeholder 3"/>
-          <p:cNvSpPr>
-            <a:spLocks noGrp="1"/>
-          </p:cNvSpPr>
-          <p:nvPr>
-            <p:ph type="sldNum" idx="5" sz="quarter"/>
-          </p:nvPr>
-        </p:nvSpPr>
-        <p:spPr/>
-      </p:sp>
-    </p:spTree>
-  </p:cSld>
-  <p:clrMapOvr>
-    <a:masterClrMapping/>
-  </p:clrMapOvr>
-</p:notes>
-</file>
-
-<file path=ppt/notesSlides/notesSlide19.xml><?xml version="1.0" encoding="utf-8"?>
-<p:notes xmlns:a="http://schemas.openxmlformats.org/drawingml/2006/main" xmlns:p="http://schemas.openxmlformats.org/presentationml/2006/main" xmlns:r="http://schemas.openxmlformats.org/officeDocument/2006/relationships">
-  <p:cSld>
-    <p:spTree>
-      <p:nvGrpSpPr>
-        <p:cNvPr id="1" name=""/>
-        <p:cNvGrpSpPr/>
-        <p:nvPr/>
-      </p:nvGrpSpPr>
-      <p:grpSpPr>
-        <a:xfrm>
-          <a:off x="0" y="0"/>
-          <a:ext cx="0" cy="0"/>
-          <a:chOff x="0" y="0"/>
-          <a:chExt cx="0" cy="0"/>
-        </a:xfrm>
-      </p:grpSpPr>
-      <p:sp>
-        <p:nvSpPr>
-          <p:cNvPr id="2" name="Slide Image Placeholder 1"/>
-          <p:cNvSpPr>
-            <a:spLocks noGrp="1"/>
-          </p:cNvSpPr>
-          <p:nvPr>
-            <p:ph type="sldImg" idx="2"/>
-          </p:nvPr>
-        </p:nvSpPr>
-        <p:spPr/>
-      </p:sp>
-      <p:sp>
-        <p:nvSpPr>
-          <p:cNvPr id="3" name="Notes Placeholder 2"/>
-          <p:cNvSpPr>
-            <a:spLocks noGrp="1"/>
-          </p:cNvSpPr>
-          <p:nvPr>
-            <p:ph type="body" idx="3" sz="quarter"/>
-          </p:nvPr>
-        </p:nvSpPr>
-        <p:spPr/>
-        <p:txBody>
-          <a:bodyPr/>
-          <a:lstStyle/>
-          <a:p/>
-        </p:txBody>
-      </p:sp>
-      <p:sp>
-        <p:nvSpPr>
-          <p:cNvPr id="4" name="Slide Number Placeholder 3"/>
-          <p:cNvSpPr>
-            <a:spLocks noGrp="1"/>
-          </p:cNvSpPr>
-          <p:nvPr>
-            <p:ph type="sldNum" idx="5" sz="quarter"/>
-          </p:nvPr>
-        </p:nvSpPr>
-        <p:spPr/>
-      </p:sp>
-    </p:spTree>
-  </p:cSld>
-  <p:clrMapOvr>
-    <a:masterClrMapping/>
-  </p:clrMapOvr>
-</p:notes>
-</file>
-
-<file path=ppt/notesSlides/notesSlide2.xml><?xml version="1.0" encoding="utf-8"?>
-<p:notes xmlns:a="http://schemas.openxmlformats.org/drawingml/2006/main" xmlns:p="http://schemas.openxmlformats.org/presentationml/2006/main" xmlns:r="http://schemas.openxmlformats.org/officeDocument/2006/relationships">
-  <p:cSld>
-    <p:spTree>
-      <p:nvGrpSpPr>
-        <p:cNvPr id="1" name=""/>
-        <p:cNvGrpSpPr/>
-        <p:nvPr/>
-      </p:nvGrpSpPr>
-      <p:grpSpPr>
-        <a:xfrm>
-          <a:off x="0" y="0"/>
-          <a:ext cx="0" cy="0"/>
-          <a:chOff x="0" y="0"/>
-          <a:chExt cx="0" cy="0"/>
-        </a:xfrm>
-      </p:grpSpPr>
-      <p:sp>
-        <p:nvSpPr>
-          <p:cNvPr id="2" name="Slide Image Placeholder 1"/>
-          <p:cNvSpPr>
-            <a:spLocks noGrp="1"/>
-          </p:cNvSpPr>
-          <p:nvPr>
-            <p:ph type="sldImg" idx="2"/>
-          </p:nvPr>
-        </p:nvSpPr>
-        <p:spPr/>
-      </p:sp>
-      <p:sp>
-        <p:nvSpPr>
-          <p:cNvPr id="3" name="Notes Placeholder 2"/>
-          <p:cNvSpPr>
-            <a:spLocks noGrp="1"/>
-          </p:cNvSpPr>
-          <p:nvPr>
-            <p:ph type="body" idx="3" sz="quarter"/>
-          </p:nvPr>
-        </p:nvSpPr>
-        <p:spPr/>
-        <p:txBody>
-          <a:bodyPr/>
-          <a:lstStyle/>
-          <a:p/>
-        </p:txBody>
-      </p:sp>
-      <p:sp>
-        <p:nvSpPr>
-          <p:cNvPr id="4" name="Slide Number Placeholder 3"/>
-          <p:cNvSpPr>
-            <a:spLocks noGrp="1"/>
-          </p:cNvSpPr>
-          <p:nvPr>
-            <p:ph type="sldNum" idx="5" sz="quarter"/>
-          </p:nvPr>
-        </p:nvSpPr>
-        <p:spPr/>
-      </p:sp>
-    </p:spTree>
-  </p:cSld>
-  <p:clrMapOvr>
-    <a:masterClrMapping/>
-  </p:clrMapOvr>
-</p:notes>
-</file>
-
-<file path=ppt/notesSlides/notesSlide20.xml><?xml version="1.0" encoding="utf-8"?>
-<p:notes xmlns:a="http://schemas.openxmlformats.org/drawingml/2006/main" xmlns:p="http://schemas.openxmlformats.org/presentationml/2006/main" xmlns:r="http://schemas.openxmlformats.org/officeDocument/2006/relationships">
-  <p:cSld>
-    <p:spTree>
-      <p:nvGrpSpPr>
-        <p:cNvPr id="1" name=""/>
-        <p:cNvGrpSpPr/>
-        <p:nvPr/>
-      </p:nvGrpSpPr>
-      <p:grpSpPr>
-        <a:xfrm>
-          <a:off x="0" y="0"/>
-          <a:ext cx="0" cy="0"/>
-          <a:chOff x="0" y="0"/>
-          <a:chExt cx="0" cy="0"/>
-        </a:xfrm>
-      </p:grpSpPr>
-      <p:sp>
-        <p:nvSpPr>
-          <p:cNvPr id="2" name="Slide Image Placeholder 1"/>
-          <p:cNvSpPr>
-            <a:spLocks noGrp="1"/>
-          </p:cNvSpPr>
-          <p:nvPr>
-            <p:ph type="sldImg" idx="2"/>
-          </p:nvPr>
-        </p:nvSpPr>
-        <p:spPr/>
-      </p:sp>
-      <p:sp>
-        <p:nvSpPr>
-          <p:cNvPr id="3" name="Notes Placeholder 2"/>
-          <p:cNvSpPr>
-            <a:spLocks noGrp="1"/>
-          </p:cNvSpPr>
-          <p:nvPr>
-            <p:ph type="body" idx="3" sz="quarter"/>
-          </p:nvPr>
-        </p:nvSpPr>
-        <p:spPr/>
-        <p:txBody>
-          <a:bodyPr/>
-          <a:lstStyle/>
-          <a:p/>
-        </p:txBody>
-      </p:sp>
-      <p:sp>
-        <p:nvSpPr>
-          <p:cNvPr id="4" name="Slide Number Placeholder 3"/>
-          <p:cNvSpPr>
-            <a:spLocks noGrp="1"/>
-          </p:cNvSpPr>
-          <p:nvPr>
-            <p:ph type="sldNum" idx="5" sz="quarter"/>
-          </p:nvPr>
-        </p:nvSpPr>
-        <p:spPr/>
-      </p:sp>
-    </p:spTree>
-  </p:cSld>
-  <p:clrMapOvr>
-    <a:masterClrMapping/>
-  </p:clrMapOvr>
-</p:notes>
-</file>
-
-<file path=ppt/notesSlides/notesSlide21.xml><?xml version="1.0" encoding="utf-8"?>
-<p:notes xmlns:a="http://schemas.openxmlformats.org/drawingml/2006/main" xmlns:p="http://schemas.openxmlformats.org/presentationml/2006/main" xmlns:r="http://schemas.openxmlformats.org/officeDocument/2006/relationships">
-  <p:cSld>
-    <p:spTree>
-      <p:nvGrpSpPr>
-        <p:cNvPr id="1" name=""/>
-        <p:cNvGrpSpPr/>
-        <p:nvPr/>
-      </p:nvGrpSpPr>
-      <p:grpSpPr>
-        <a:xfrm>
-          <a:off x="0" y="0"/>
-          <a:ext cx="0" cy="0"/>
-          <a:chOff x="0" y="0"/>
-          <a:chExt cx="0" cy="0"/>
-        </a:xfrm>
-      </p:grpSpPr>
-      <p:sp>
-        <p:nvSpPr>
-          <p:cNvPr id="2" name="Slide Image Placeholder 1"/>
-          <p:cNvSpPr>
-            <a:spLocks noGrp="1"/>
-          </p:cNvSpPr>
-          <p:nvPr>
-            <p:ph type="sldImg" idx="2"/>
-          </p:nvPr>
-        </p:nvSpPr>
-        <p:spPr/>
-      </p:sp>
-      <p:sp>
-        <p:nvSpPr>
-          <p:cNvPr id="3" name="Notes Placeholder 2"/>
-          <p:cNvSpPr>
-            <a:spLocks noGrp="1"/>
-          </p:cNvSpPr>
-          <p:nvPr>
-            <p:ph type="body" idx="3" sz="quarter"/>
-          </p:nvPr>
-        </p:nvSpPr>
-        <p:spPr/>
-        <p:txBody>
-          <a:bodyPr/>
-          <a:lstStyle/>
-          <a:p/>
-        </p:txBody>
-      </p:sp>
-      <p:sp>
-        <p:nvSpPr>
-          <p:cNvPr id="4" name="Slide Number Placeholder 3"/>
-          <p:cNvSpPr>
-            <a:spLocks noGrp="1"/>
-          </p:cNvSpPr>
-          <p:nvPr>
-            <p:ph type="sldNum" idx="5" sz="quarter"/>
-          </p:nvPr>
-        </p:nvSpPr>
-        <p:spPr/>
-      </p:sp>
-    </p:spTree>
-  </p:cSld>
-  <p:clrMapOvr>
-    <a:masterClrMapping/>
-  </p:clrMapOvr>
-</p:notes>
-</file>
-
-<file path=ppt/notesSlides/notesSlide22.xml><?xml version="1.0" encoding="utf-8"?>
-<p:notes xmlns:a="http://schemas.openxmlformats.org/drawingml/2006/main" xmlns:p="http://schemas.openxmlformats.org/presentationml/2006/main" xmlns:r="http://schemas.openxmlformats.org/officeDocument/2006/relationships">
-  <p:cSld>
-    <p:spTree>
-      <p:nvGrpSpPr>
-        <p:cNvPr id="1" name=""/>
-        <p:cNvGrpSpPr/>
-        <p:nvPr/>
-      </p:nvGrpSpPr>
-      <p:grpSpPr>
-        <a:xfrm>
-          <a:off x="0" y="0"/>
-          <a:ext cx="0" cy="0"/>
-          <a:chOff x="0" y="0"/>
-          <a:chExt cx="0" cy="0"/>
-        </a:xfrm>
-      </p:grpSpPr>
-      <p:sp>
-        <p:nvSpPr>
-          <p:cNvPr id="2" name="Slide Image Placeholder 1"/>
-          <p:cNvSpPr>
-            <a:spLocks noGrp="1"/>
-          </p:cNvSpPr>
-          <p:nvPr>
-            <p:ph type="sldImg" idx="2"/>
-          </p:nvPr>
-        </p:nvSpPr>
-        <p:spPr/>
-      </p:sp>
-      <p:sp>
-        <p:nvSpPr>
-          <p:cNvPr id="3" name="Notes Placeholder 2"/>
-          <p:cNvSpPr>
-            <a:spLocks noGrp="1"/>
-          </p:cNvSpPr>
-          <p:nvPr>
-            <p:ph type="body" idx="3" sz="quarter"/>
-          </p:nvPr>
-        </p:nvSpPr>
-        <p:spPr/>
-        <p:txBody>
-          <a:bodyPr/>
-          <a:lstStyle/>
-          <a:p/>
-        </p:txBody>
-      </p:sp>
-      <p:sp>
-        <p:nvSpPr>
-          <p:cNvPr id="4" name="Slide Number Placeholder 3"/>
-          <p:cNvSpPr>
-            <a:spLocks noGrp="1"/>
-          </p:cNvSpPr>
-          <p:nvPr>
-            <p:ph type="sldNum" idx="5" sz="quarter"/>
-          </p:nvPr>
-        </p:nvSpPr>
-        <p:spPr/>
-      </p:sp>
-    </p:spTree>
-  </p:cSld>
-  <p:clrMapOvr>
-    <a:masterClrMapping/>
-  </p:clrMapOvr>
-</p:notes>
-</file>
-
-<file path=ppt/notesSlides/notesSlide23.xml><?xml version="1.0" encoding="utf-8"?>
-<p:notes xmlns:a="http://schemas.openxmlformats.org/drawingml/2006/main" xmlns:p="http://schemas.openxmlformats.org/presentationml/2006/main" xmlns:r="http://schemas.openxmlformats.org/officeDocument/2006/relationships">
-  <p:cSld>
-    <p:spTree>
-      <p:nvGrpSpPr>
-        <p:cNvPr id="1" name=""/>
-        <p:cNvGrpSpPr/>
-        <p:nvPr/>
-      </p:nvGrpSpPr>
-      <p:grpSpPr>
-        <a:xfrm>
-          <a:off x="0" y="0"/>
-          <a:ext cx="0" cy="0"/>
-          <a:chOff x="0" y="0"/>
-          <a:chExt cx="0" cy="0"/>
-        </a:xfrm>
-      </p:grpSpPr>
-      <p:sp>
-        <p:nvSpPr>
-          <p:cNvPr id="2" name="Slide Image Placeholder 1"/>
-          <p:cNvSpPr>
-            <a:spLocks noGrp="1"/>
-          </p:cNvSpPr>
-          <p:nvPr>
-            <p:ph type="sldImg" idx="2"/>
-          </p:nvPr>
-        </p:nvSpPr>
-        <p:spPr/>
-      </p:sp>
-      <p:sp>
-        <p:nvSpPr>
-          <p:cNvPr id="3" name="Notes Placeholder 2"/>
-          <p:cNvSpPr>
-            <a:spLocks noGrp="1"/>
-          </p:cNvSpPr>
-          <p:nvPr>
-            <p:ph type="body" idx="3" sz="quarter"/>
-          </p:nvPr>
-        </p:nvSpPr>
-        <p:spPr/>
-        <p:txBody>
-          <a:bodyPr/>
-          <a:lstStyle/>
-          <a:p/>
-        </p:txBody>
-      </p:sp>
-      <p:sp>
-        <p:nvSpPr>
-          <p:cNvPr id="4" name="Slide Number Placeholder 3"/>
-          <p:cNvSpPr>
-            <a:spLocks noGrp="1"/>
-          </p:cNvSpPr>
-          <p:nvPr>
-            <p:ph type="sldNum" idx="5" sz="quarter"/>
-          </p:nvPr>
-        </p:nvSpPr>
-        <p:spPr/>
-      </p:sp>
-    </p:spTree>
-  </p:cSld>
-  <p:clrMapOvr>
-    <a:masterClrMapping/>
-  </p:clrMapOvr>
-</p:notes>
-</file>
-
-<file path=ppt/notesSlides/notesSlide24.xml><?xml version="1.0" encoding="utf-8"?>
-<p:notes xmlns:a="http://schemas.openxmlformats.org/drawingml/2006/main" xmlns:p="http://schemas.openxmlformats.org/presentationml/2006/main" xmlns:r="http://schemas.openxmlformats.org/officeDocument/2006/relationships">
-  <p:cSld>
-    <p:spTree>
-      <p:nvGrpSpPr>
-        <p:cNvPr id="1" name=""/>
-        <p:cNvGrpSpPr/>
-        <p:nvPr/>
-      </p:nvGrpSpPr>
-      <p:grpSpPr>
-        <a:xfrm>
-          <a:off x="0" y="0"/>
-          <a:ext cx="0" cy="0"/>
-          <a:chOff x="0" y="0"/>
-          <a:chExt cx="0" cy="0"/>
-        </a:xfrm>
-      </p:grpSpPr>
-      <p:sp>
-        <p:nvSpPr>
-          <p:cNvPr id="2" name="Slide Image Placeholder 1"/>
-          <p:cNvSpPr>
-            <a:spLocks noGrp="1"/>
-          </p:cNvSpPr>
-          <p:nvPr>
-            <p:ph type="sldImg" idx="2"/>
-          </p:nvPr>
-        </p:nvSpPr>
-        <p:spPr/>
-      </p:sp>
-      <p:sp>
-        <p:nvSpPr>
-          <p:cNvPr id="3" name="Notes Placeholder 2"/>
-          <p:cNvSpPr>
-            <a:spLocks noGrp="1"/>
-          </p:cNvSpPr>
-          <p:nvPr>
-            <p:ph type="body" idx="3" sz="quarter"/>
-          </p:nvPr>
-        </p:nvSpPr>
-        <p:spPr/>
-        <p:txBody>
-          <a:bodyPr/>
-          <a:lstStyle/>
-          <a:p/>
-        </p:txBody>
-      </p:sp>
-      <p:sp>
-        <p:nvSpPr>
-          <p:cNvPr id="4" name="Slide Number Placeholder 3"/>
-          <p:cNvSpPr>
-            <a:spLocks noGrp="1"/>
-          </p:cNvSpPr>
-          <p:nvPr>
-            <p:ph type="sldNum" idx="5" sz="quarter"/>
-          </p:nvPr>
-        </p:nvSpPr>
-        <p:spPr/>
-      </p:sp>
-    </p:spTree>
-  </p:cSld>
-  <p:clrMapOvr>
-    <a:masterClrMapping/>
-  </p:clrMapOvr>
-</p:notes>
-</file>
-
-<file path=ppt/notesSlides/notesSlide25.xml><?xml version="1.0" encoding="utf-8"?>
-<p:notes xmlns:a="http://schemas.openxmlformats.org/drawingml/2006/main" xmlns:p="http://schemas.openxmlformats.org/presentationml/2006/main" xmlns:r="http://schemas.openxmlformats.org/officeDocument/2006/relationships">
-  <p:cSld>
-    <p:spTree>
-      <p:nvGrpSpPr>
-        <p:cNvPr id="1" name=""/>
-        <p:cNvGrpSpPr/>
-        <p:nvPr/>
-      </p:nvGrpSpPr>
-      <p:grpSpPr>
-        <a:xfrm>
-          <a:off x="0" y="0"/>
-          <a:ext cx="0" cy="0"/>
-          <a:chOff x="0" y="0"/>
-          <a:chExt cx="0" cy="0"/>
-        </a:xfrm>
-      </p:grpSpPr>
-      <p:sp>
-        <p:nvSpPr>
-          <p:cNvPr id="2" name="Slide Image Placeholder 1"/>
-          <p:cNvSpPr>
-            <a:spLocks noGrp="1"/>
-          </p:cNvSpPr>
-          <p:nvPr>
-            <p:ph type="sldImg" idx="2"/>
-          </p:nvPr>
-        </p:nvSpPr>
-        <p:spPr/>
-      </p:sp>
-      <p:sp>
-        <p:nvSpPr>
-          <p:cNvPr id="3" name="Notes Placeholder 2"/>
-          <p:cNvSpPr>
-            <a:spLocks noGrp="1"/>
-          </p:cNvSpPr>
-          <p:nvPr>
-            <p:ph type="body" idx="3" sz="quarter"/>
-          </p:nvPr>
-        </p:nvSpPr>
-        <p:spPr/>
-        <p:txBody>
-          <a:bodyPr/>
-          <a:lstStyle/>
-          <a:p/>
-        </p:txBody>
-      </p:sp>
-      <p:sp>
-        <p:nvSpPr>
-          <p:cNvPr id="4" name="Slide Number Placeholder 3"/>
-          <p:cNvSpPr>
-            <a:spLocks noGrp="1"/>
-          </p:cNvSpPr>
-          <p:nvPr>
-            <p:ph type="sldNum" idx="5" sz="quarter"/>
-          </p:nvPr>
-        </p:nvSpPr>
-        <p:spPr/>
-      </p:sp>
-    </p:spTree>
-  </p:cSld>
-  <p:clrMapOvr>
-    <a:masterClrMapping/>
-  </p:clrMapOvr>
-</p:notes>
-</file>
-
-<file path=ppt/notesSlides/notesSlide26.xml><?xml version="1.0" encoding="utf-8"?>
-<p:notes xmlns:a="http://schemas.openxmlformats.org/drawingml/2006/main" xmlns:p="http://schemas.openxmlformats.org/presentationml/2006/main" xmlns:r="http://schemas.openxmlformats.org/officeDocument/2006/relationships">
-  <p:cSld>
-    <p:spTree>
-      <p:nvGrpSpPr>
-        <p:cNvPr id="1" name=""/>
-        <p:cNvGrpSpPr/>
-        <p:nvPr/>
-      </p:nvGrpSpPr>
-      <p:grpSpPr>
-        <a:xfrm>
-          <a:off x="0" y="0"/>
-          <a:ext cx="0" cy="0"/>
-          <a:chOff x="0" y="0"/>
-          <a:chExt cx="0" cy="0"/>
-        </a:xfrm>
-      </p:grpSpPr>
-      <p:sp>
-        <p:nvSpPr>
-          <p:cNvPr id="2" name="Slide Image Placeholder 1"/>
-          <p:cNvSpPr>
-            <a:spLocks noGrp="1"/>
-          </p:cNvSpPr>
-          <p:nvPr>
-            <p:ph type="sldImg" idx="2"/>
-          </p:nvPr>
-        </p:nvSpPr>
-        <p:spPr/>
-      </p:sp>
-      <p:sp>
-        <p:nvSpPr>
-          <p:cNvPr id="3" name="Notes Placeholder 2"/>
-          <p:cNvSpPr>
-            <a:spLocks noGrp="1"/>
-          </p:cNvSpPr>
-          <p:nvPr>
-            <p:ph type="body" idx="3" sz="quarter"/>
-          </p:nvPr>
-        </p:nvSpPr>
-        <p:spPr/>
-        <p:txBody>
-          <a:bodyPr/>
-          <a:lstStyle/>
-          <a:p/>
-        </p:txBody>
-      </p:sp>
-      <p:sp>
-        <p:nvSpPr>
-          <p:cNvPr id="4" name="Slide Number Placeholder 3"/>
-          <p:cNvSpPr>
-            <a:spLocks noGrp="1"/>
-          </p:cNvSpPr>
-          <p:nvPr>
-            <p:ph type="sldNum" idx="5" sz="quarter"/>
-          </p:nvPr>
-        </p:nvSpPr>
-        <p:spPr/>
-      </p:sp>
-    </p:spTree>
-  </p:cSld>
-  <p:clrMapOvr>
-    <a:masterClrMapping/>
-  </p:clrMapOvr>
-</p:notes>
-</file>
-
-<file path=ppt/notesSlides/notesSlide27.xml><?xml version="1.0" encoding="utf-8"?>
-<p:notes xmlns:a="http://schemas.openxmlformats.org/drawingml/2006/main" xmlns:p="http://schemas.openxmlformats.org/presentationml/2006/main" xmlns:r="http://schemas.openxmlformats.org/officeDocument/2006/relationships">
-  <p:cSld>
-    <p:spTree>
-      <p:nvGrpSpPr>
-        <p:cNvPr id="1" name=""/>
-        <p:cNvGrpSpPr/>
-        <p:nvPr/>
-      </p:nvGrpSpPr>
-      <p:grpSpPr>
-        <a:xfrm>
-          <a:off x="0" y="0"/>
-          <a:ext cx="0" cy="0"/>
-          <a:chOff x="0" y="0"/>
-          <a:chExt cx="0" cy="0"/>
-        </a:xfrm>
-      </p:grpSpPr>
-      <p:sp>
-        <p:nvSpPr>
-          <p:cNvPr id="2" name="Slide Image Placeholder 1"/>
-          <p:cNvSpPr>
-            <a:spLocks noGrp="1"/>
-          </p:cNvSpPr>
-          <p:nvPr>
-            <p:ph type="sldImg" idx="2"/>
-          </p:nvPr>
-        </p:nvSpPr>
-        <p:spPr/>
-      </p:sp>
-      <p:sp>
-        <p:nvSpPr>
-          <p:cNvPr id="3" name="Notes Placeholder 2"/>
-          <p:cNvSpPr>
-            <a:spLocks noGrp="1"/>
-          </p:cNvSpPr>
-          <p:nvPr>
-            <p:ph type="body" idx="3" sz="quarter"/>
-          </p:nvPr>
-        </p:nvSpPr>
-        <p:spPr/>
-        <p:txBody>
-          <a:bodyPr/>
-          <a:lstStyle/>
-          <a:p/>
-        </p:txBody>
-      </p:sp>
-      <p:sp>
-        <p:nvSpPr>
-          <p:cNvPr id="4" name="Slide Number Placeholder 3"/>
-          <p:cNvSpPr>
-            <a:spLocks noGrp="1"/>
-          </p:cNvSpPr>
-          <p:nvPr>
-            <p:ph type="sldNum" idx="5" sz="quarter"/>
-          </p:nvPr>
-        </p:nvSpPr>
-        <p:spPr/>
-      </p:sp>
-    </p:spTree>
-  </p:cSld>
-  <p:clrMapOvr>
-    <a:masterClrMapping/>
-  </p:clrMapOvr>
-</p:notes>
-</file>
-
-<file path=ppt/notesSlides/notesSlide28.xml><?xml version="1.0" encoding="utf-8"?>
-<p:notes xmlns:a="http://schemas.openxmlformats.org/drawingml/2006/main" xmlns:p="http://schemas.openxmlformats.org/presentationml/2006/main" xmlns:r="http://schemas.openxmlformats.org/officeDocument/2006/relationships">
-  <p:cSld>
-    <p:spTree>
-      <p:nvGrpSpPr>
-        <p:cNvPr id="1" name=""/>
-        <p:cNvGrpSpPr/>
-        <p:nvPr/>
-      </p:nvGrpSpPr>
-      <p:grpSpPr>
-        <a:xfrm>
-          <a:off x="0" y="0"/>
-          <a:ext cx="0" cy="0"/>
-          <a:chOff x="0" y="0"/>
-          <a:chExt cx="0" cy="0"/>
-        </a:xfrm>
-      </p:grpSpPr>
-      <p:sp>
-        <p:nvSpPr>
-          <p:cNvPr id="2" name="Slide Image Placeholder 1"/>
-          <p:cNvSpPr>
-            <a:spLocks noGrp="1"/>
-          </p:cNvSpPr>
-          <p:nvPr>
-            <p:ph type="sldImg" idx="2"/>
-          </p:nvPr>
-        </p:nvSpPr>
-        <p:spPr/>
-      </p:sp>
-      <p:sp>
-        <p:nvSpPr>
-          <p:cNvPr id="3" name="Notes Placeholder 2"/>
-          <p:cNvSpPr>
-            <a:spLocks noGrp="1"/>
-          </p:cNvSpPr>
-          <p:nvPr>
-            <p:ph type="body" idx="3" sz="quarter"/>
-          </p:nvPr>
-        </p:nvSpPr>
-        <p:spPr/>
-        <p:txBody>
-          <a:bodyPr/>
-          <a:lstStyle/>
-          <a:p/>
-        </p:txBody>
-      </p:sp>
-      <p:sp>
-        <p:nvSpPr>
-          <p:cNvPr id="4" name="Slide Number Placeholder 3"/>
-          <p:cNvSpPr>
-            <a:spLocks noGrp="1"/>
-          </p:cNvSpPr>
-          <p:nvPr>
-            <p:ph type="sldNum" idx="5" sz="quarter"/>
-          </p:nvPr>
-        </p:nvSpPr>
-        <p:spPr/>
-      </p:sp>
-    </p:spTree>
-  </p:cSld>
-  <p:clrMapOvr>
-    <a:masterClrMapping/>
-  </p:clrMapOvr>
-</p:notes>
-</file>
-
-<file path=ppt/notesSlides/notesSlide29.xml><?xml version="1.0" encoding="utf-8"?>
-<p:notes xmlns:a="http://schemas.openxmlformats.org/drawingml/2006/main" xmlns:p="http://schemas.openxmlformats.org/presentationml/2006/main" xmlns:r="http://schemas.openxmlformats.org/officeDocument/2006/relationships">
-  <p:cSld>
-    <p:spTree>
-      <p:nvGrpSpPr>
-        <p:cNvPr id="1" name=""/>
-        <p:cNvGrpSpPr/>
-        <p:nvPr/>
-      </p:nvGrpSpPr>
-      <p:grpSpPr>
-        <a:xfrm>
-          <a:off x="0" y="0"/>
-          <a:ext cx="0" cy="0"/>
-          <a:chOff x="0" y="0"/>
-          <a:chExt cx="0" cy="0"/>
-        </a:xfrm>
-      </p:grpSpPr>
-      <p:sp>
-        <p:nvSpPr>
-          <p:cNvPr id="2" name="Slide Image Placeholder 1"/>
-          <p:cNvSpPr>
-            <a:spLocks noGrp="1"/>
-          </p:cNvSpPr>
-          <p:nvPr>
-            <p:ph type="sldImg" idx="2"/>
-          </p:nvPr>
-        </p:nvSpPr>
-        <p:spPr/>
-      </p:sp>
-      <p:sp>
-        <p:nvSpPr>
-          <p:cNvPr id="3" name="Notes Placeholder 2"/>
-          <p:cNvSpPr>
-            <a:spLocks noGrp="1"/>
-          </p:cNvSpPr>
-          <p:nvPr>
-            <p:ph type="body" idx="3" sz="quarter"/>
-          </p:nvPr>
-        </p:nvSpPr>
-        <p:spPr/>
-        <p:txBody>
-          <a:bodyPr/>
-          <a:lstStyle/>
-          <a:p/>
-        </p:txBody>
-      </p:sp>
-      <p:sp>
-        <p:nvSpPr>
-          <p:cNvPr id="4" name="Slide Number Placeholder 3"/>
-          <p:cNvSpPr>
-            <a:spLocks noGrp="1"/>
-          </p:cNvSpPr>
-          <p:nvPr>
-            <p:ph type="sldNum" idx="5" sz="quarter"/>
-          </p:nvPr>
-        </p:nvSpPr>
-        <p:spPr/>
-      </p:sp>
-    </p:spTree>
-  </p:cSld>
-  <p:clrMapOvr>
-    <a:masterClrMapping/>
-  </p:clrMapOvr>
-</p:notes>
-</file>
-
-<file path=ppt/notesSlides/notesSlide3.xml><?xml version="1.0" encoding="utf-8"?>
-<p:notes xmlns:a="http://schemas.openxmlformats.org/drawingml/2006/main" xmlns:p="http://schemas.openxmlformats.org/presentationml/2006/main" xmlns:r="http://schemas.openxmlformats.org/officeDocument/2006/relationships">
-  <p:cSld>
-    <p:spTree>
-      <p:nvGrpSpPr>
-        <p:cNvPr id="1" name=""/>
-        <p:cNvGrpSpPr/>
-        <p:nvPr/>
-      </p:nvGrpSpPr>
-      <p:grpSpPr>
-        <a:xfrm>
-          <a:off x="0" y="0"/>
-          <a:ext cx="0" cy="0"/>
-          <a:chOff x="0" y="0"/>
-          <a:chExt cx="0" cy="0"/>
-        </a:xfrm>
-      </p:grpSpPr>
-      <p:sp>
-        <p:nvSpPr>
-          <p:cNvPr id="2" name="Slide Image Placeholder 1"/>
-          <p:cNvSpPr>
-            <a:spLocks noGrp="1"/>
-          </p:cNvSpPr>
-          <p:nvPr>
-            <p:ph type="sldImg" idx="2"/>
-          </p:nvPr>
-        </p:nvSpPr>
-        <p:spPr/>
-      </p:sp>
-      <p:sp>
-        <p:nvSpPr>
-          <p:cNvPr id="3" name="Notes Placeholder 2"/>
-          <p:cNvSpPr>
-            <a:spLocks noGrp="1"/>
-          </p:cNvSpPr>
-          <p:nvPr>
-            <p:ph type="body" idx="3" sz="quarter"/>
-          </p:nvPr>
-        </p:nvSpPr>
-        <p:spPr/>
-        <p:txBody>
-          <a:bodyPr/>
-          <a:lstStyle/>
-          <a:p/>
-        </p:txBody>
-      </p:sp>
-      <p:sp>
-        <p:nvSpPr>
-          <p:cNvPr id="4" name="Slide Number Placeholder 3"/>
-          <p:cNvSpPr>
-            <a:spLocks noGrp="1"/>
-          </p:cNvSpPr>
-          <p:nvPr>
-            <p:ph type="sldNum" idx="5" sz="quarter"/>
-          </p:nvPr>
-        </p:nvSpPr>
-        <p:spPr/>
-      </p:sp>
-    </p:spTree>
-  </p:cSld>
-  <p:clrMapOvr>
-    <a:masterClrMapping/>
-  </p:clrMapOvr>
-</p:notes>
-</file>
-
-<file path=ppt/notesSlides/notesSlide30.xml><?xml version="1.0" encoding="utf-8"?>
-<p:notes xmlns:a="http://schemas.openxmlformats.org/drawingml/2006/main" xmlns:p="http://schemas.openxmlformats.org/presentationml/2006/main" xmlns:r="http://schemas.openxmlformats.org/officeDocument/2006/relationships">
-  <p:cSld>
-    <p:spTree>
-      <p:nvGrpSpPr>
-        <p:cNvPr id="1" name=""/>
-        <p:cNvGrpSpPr/>
-        <p:nvPr/>
-      </p:nvGrpSpPr>
-      <p:grpSpPr>
-        <a:xfrm>
-          <a:off x="0" y="0"/>
-          <a:ext cx="0" cy="0"/>
-          <a:chOff x="0" y="0"/>
-          <a:chExt cx="0" cy="0"/>
-        </a:xfrm>
-      </p:grpSpPr>
-      <p:sp>
-        <p:nvSpPr>
-          <p:cNvPr id="2" name="Slide Image Placeholder 1"/>
-          <p:cNvSpPr>
-            <a:spLocks noGrp="1"/>
-          </p:cNvSpPr>
-          <p:nvPr>
-            <p:ph type="sldImg" idx="2"/>
-          </p:nvPr>
-        </p:nvSpPr>
-        <p:spPr/>
-      </p:sp>
-      <p:sp>
-        <p:nvSpPr>
-          <p:cNvPr id="3" name="Notes Placeholder 2"/>
-          <p:cNvSpPr>
-            <a:spLocks noGrp="1"/>
-          </p:cNvSpPr>
-          <p:nvPr>
-            <p:ph type="body" idx="3" sz="quarter"/>
-          </p:nvPr>
-        </p:nvSpPr>
-        <p:spPr/>
-        <p:txBody>
-          <a:bodyPr/>
-          <a:lstStyle/>
-          <a:p/>
-        </p:txBody>
-      </p:sp>
-      <p:sp>
-        <p:nvSpPr>
-          <p:cNvPr id="4" name="Slide Number Placeholder 3"/>
-          <p:cNvSpPr>
-            <a:spLocks noGrp="1"/>
-          </p:cNvSpPr>
-          <p:nvPr>
-            <p:ph type="sldNum" idx="5" sz="quarter"/>
-          </p:nvPr>
-        </p:nvSpPr>
-        <p:spPr/>
-      </p:sp>
-    </p:spTree>
-  </p:cSld>
-  <p:clrMapOvr>
-    <a:masterClrMapping/>
-  </p:clrMapOvr>
-</p:notes>
-</file>
-
-<file path=ppt/notesSlides/notesSlide4.xml><?xml version="1.0" encoding="utf-8"?>
-<p:notes xmlns:a="http://schemas.openxmlformats.org/drawingml/2006/main" xmlns:p="http://schemas.openxmlformats.org/presentationml/2006/main" xmlns:r="http://schemas.openxmlformats.org/officeDocument/2006/relationships">
-  <p:cSld>
-    <p:spTree>
-      <p:nvGrpSpPr>
-        <p:cNvPr id="1" name=""/>
-        <p:cNvGrpSpPr/>
-        <p:nvPr/>
-      </p:nvGrpSpPr>
-      <p:grpSpPr>
-        <a:xfrm>
-          <a:off x="0" y="0"/>
-          <a:ext cx="0" cy="0"/>
-          <a:chOff x="0" y="0"/>
-          <a:chExt cx="0" cy="0"/>
-        </a:xfrm>
-      </p:grpSpPr>
-      <p:sp>
-        <p:nvSpPr>
-          <p:cNvPr id="2" name="Slide Image Placeholder 1"/>
-          <p:cNvSpPr>
-            <a:spLocks noGrp="1"/>
-          </p:cNvSpPr>
-          <p:nvPr>
-            <p:ph type="sldImg" idx="2"/>
-          </p:nvPr>
-        </p:nvSpPr>
-        <p:spPr/>
-      </p:sp>
-      <p:sp>
-        <p:nvSpPr>
-          <p:cNvPr id="3" name="Notes Placeholder 2"/>
-          <p:cNvSpPr>
-            <a:spLocks noGrp="1"/>
-          </p:cNvSpPr>
-          <p:nvPr>
-            <p:ph type="body" idx="3" sz="quarter"/>
-          </p:nvPr>
-        </p:nvSpPr>
-        <p:spPr/>
-        <p:txBody>
-          <a:bodyPr/>
-          <a:lstStyle/>
-          <a:p/>
-        </p:txBody>
-      </p:sp>
-      <p:sp>
-        <p:nvSpPr>
-          <p:cNvPr id="4" name="Slide Number Placeholder 3"/>
-          <p:cNvSpPr>
-            <a:spLocks noGrp="1"/>
-          </p:cNvSpPr>
-          <p:nvPr>
-            <p:ph type="sldNum" idx="5" sz="quarter"/>
-          </p:nvPr>
-        </p:nvSpPr>
-        <p:spPr/>
-      </p:sp>
-    </p:spTree>
-  </p:cSld>
-  <p:clrMapOvr>
-    <a:masterClrMapping/>
-  </p:clrMapOvr>
-</p:notes>
-</file>
-
-<file path=ppt/notesSlides/notesSlide5.xml><?xml version="1.0" encoding="utf-8"?>
-<p:notes xmlns:a="http://schemas.openxmlformats.org/drawingml/2006/main" xmlns:p="http://schemas.openxmlformats.org/presentationml/2006/main" xmlns:r="http://schemas.openxmlformats.org/officeDocument/2006/relationships">
-  <p:cSld>
-    <p:spTree>
-      <p:nvGrpSpPr>
-        <p:cNvPr id="1" name=""/>
-        <p:cNvGrpSpPr/>
-        <p:nvPr/>
-      </p:nvGrpSpPr>
-      <p:grpSpPr>
-        <a:xfrm>
-          <a:off x="0" y="0"/>
-          <a:ext cx="0" cy="0"/>
-          <a:chOff x="0" y="0"/>
-          <a:chExt cx="0" cy="0"/>
-        </a:xfrm>
-      </p:grpSpPr>
-      <p:sp>
-        <p:nvSpPr>
-          <p:cNvPr id="2" name="Slide Image Placeholder 1"/>
-          <p:cNvSpPr>
-            <a:spLocks noGrp="1"/>
-          </p:cNvSpPr>
-          <p:nvPr>
-            <p:ph type="sldImg" idx="2"/>
-          </p:nvPr>
-        </p:nvSpPr>
-        <p:spPr/>
-      </p:sp>
-      <p:sp>
-        <p:nvSpPr>
-          <p:cNvPr id="3" name="Notes Placeholder 2"/>
-          <p:cNvSpPr>
-            <a:spLocks noGrp="1"/>
-          </p:cNvSpPr>
-          <p:nvPr>
-            <p:ph type="body" idx="3" sz="quarter"/>
-          </p:nvPr>
-        </p:nvSpPr>
-        <p:spPr/>
-        <p:txBody>
-          <a:bodyPr/>
-          <a:lstStyle/>
-          <a:p/>
-        </p:txBody>
-      </p:sp>
-      <p:sp>
-        <p:nvSpPr>
-          <p:cNvPr id="4" name="Slide Number Placeholder 3"/>
-          <p:cNvSpPr>
-            <a:spLocks noGrp="1"/>
-          </p:cNvSpPr>
-          <p:nvPr>
-            <p:ph type="sldNum" idx="5" sz="quarter"/>
-          </p:nvPr>
-        </p:nvSpPr>
-        <p:spPr/>
-      </p:sp>
-    </p:spTree>
-  </p:cSld>
-  <p:clrMapOvr>
-    <a:masterClrMapping/>
-  </p:clrMapOvr>
-</p:notes>
-</file>
-
-<file path=ppt/notesSlides/notesSlide6.xml><?xml version="1.0" encoding="utf-8"?>
-<p:notes xmlns:a="http://schemas.openxmlformats.org/drawingml/2006/main" xmlns:p="http://schemas.openxmlformats.org/presentationml/2006/main" xmlns:r="http://schemas.openxmlformats.org/officeDocument/2006/relationships">
-  <p:cSld>
-    <p:spTree>
-      <p:nvGrpSpPr>
-        <p:cNvPr id="1" name=""/>
-        <p:cNvGrpSpPr/>
-        <p:nvPr/>
-      </p:nvGrpSpPr>
-      <p:grpSpPr>
-        <a:xfrm>
-          <a:off x="0" y="0"/>
-          <a:ext cx="0" cy="0"/>
-          <a:chOff x="0" y="0"/>
-          <a:chExt cx="0" cy="0"/>
-        </a:xfrm>
-      </p:grpSpPr>
-      <p:sp>
-        <p:nvSpPr>
-          <p:cNvPr id="2" name="Slide Image Placeholder 1"/>
-          <p:cNvSpPr>
-            <a:spLocks noGrp="1"/>
-          </p:cNvSpPr>
-          <p:nvPr>
-            <p:ph type="sldImg" idx="2"/>
-          </p:nvPr>
-        </p:nvSpPr>
-        <p:spPr/>
-      </p:sp>
-      <p:sp>
-        <p:nvSpPr>
-          <p:cNvPr id="3" name="Notes Placeholder 2"/>
-          <p:cNvSpPr>
-            <a:spLocks noGrp="1"/>
-          </p:cNvSpPr>
-          <p:nvPr>
-            <p:ph type="body" idx="3" sz="quarter"/>
-          </p:nvPr>
-        </p:nvSpPr>
-        <p:spPr/>
-        <p:txBody>
-          <a:bodyPr/>
-          <a:lstStyle/>
-          <a:p/>
-        </p:txBody>
-      </p:sp>
-      <p:sp>
-        <p:nvSpPr>
-          <p:cNvPr id="4" name="Slide Number Placeholder 3"/>
-          <p:cNvSpPr>
-            <a:spLocks noGrp="1"/>
-          </p:cNvSpPr>
-          <p:nvPr>
-            <p:ph type="sldNum" idx="5" sz="quarter"/>
-          </p:nvPr>
-        </p:nvSpPr>
-        <p:spPr/>
-      </p:sp>
-    </p:spTree>
-  </p:cSld>
-  <p:clrMapOvr>
-    <a:masterClrMapping/>
-  </p:clrMapOvr>
-</p:notes>
-</file>
-
-<file path=ppt/notesSlides/notesSlide7.xml><?xml version="1.0" encoding="utf-8"?>
-<p:notes xmlns:a="http://schemas.openxmlformats.org/drawingml/2006/main" xmlns:p="http://schemas.openxmlformats.org/presentationml/2006/main" xmlns:r="http://schemas.openxmlformats.org/officeDocument/2006/relationships">
-  <p:cSld>
-    <p:spTree>
-      <p:nvGrpSpPr>
-        <p:cNvPr id="1" name=""/>
-        <p:cNvGrpSpPr/>
-        <p:nvPr/>
-      </p:nvGrpSpPr>
-      <p:grpSpPr>
-        <a:xfrm>
-          <a:off x="0" y="0"/>
-          <a:ext cx="0" cy="0"/>
-          <a:chOff x="0" y="0"/>
-          <a:chExt cx="0" cy="0"/>
-        </a:xfrm>
-      </p:grpSpPr>
-      <p:sp>
-        <p:nvSpPr>
-          <p:cNvPr id="2" name="Slide Image Placeholder 1"/>
-          <p:cNvSpPr>
-            <a:spLocks noGrp="1"/>
-          </p:cNvSpPr>
-          <p:nvPr>
-            <p:ph type="sldImg" idx="2"/>
-          </p:nvPr>
-        </p:nvSpPr>
-        <p:spPr/>
-      </p:sp>
-      <p:sp>
-        <p:nvSpPr>
-          <p:cNvPr id="3" name="Notes Placeholder 2"/>
-          <p:cNvSpPr>
-            <a:spLocks noGrp="1"/>
-          </p:cNvSpPr>
-          <p:nvPr>
-            <p:ph type="body" idx="3" sz="quarter"/>
-          </p:nvPr>
-        </p:nvSpPr>
-        <p:spPr/>
-        <p:txBody>
-          <a:bodyPr/>
-          <a:lstStyle/>
-          <a:p/>
-        </p:txBody>
-      </p:sp>
-      <p:sp>
-        <p:nvSpPr>
-          <p:cNvPr id="4" name="Slide Number Placeholder 3"/>
-          <p:cNvSpPr>
-            <a:spLocks noGrp="1"/>
-          </p:cNvSpPr>
-          <p:nvPr>
-            <p:ph type="sldNum" idx="5" sz="quarter"/>
-          </p:nvPr>
-        </p:nvSpPr>
-        <p:spPr/>
-      </p:sp>
-    </p:spTree>
-  </p:cSld>
-  <p:clrMapOvr>
-    <a:masterClrMapping/>
-  </p:clrMapOvr>
-</p:notes>
-</file>
-
-<file path=ppt/notesSlides/notesSlide8.xml><?xml version="1.0" encoding="utf-8"?>
-<p:notes xmlns:a="http://schemas.openxmlformats.org/drawingml/2006/main" xmlns:p="http://schemas.openxmlformats.org/presentationml/2006/main" xmlns:r="http://schemas.openxmlformats.org/officeDocument/2006/relationships">
-  <p:cSld>
-    <p:spTree>
-      <p:nvGrpSpPr>
-        <p:cNvPr id="1" name=""/>
-        <p:cNvGrpSpPr/>
-        <p:nvPr/>
-      </p:nvGrpSpPr>
-      <p:grpSpPr>
-        <a:xfrm>
-          <a:off x="0" y="0"/>
-          <a:ext cx="0" cy="0"/>
-          <a:chOff x="0" y="0"/>
-          <a:chExt cx="0" cy="0"/>
-        </a:xfrm>
-      </p:grpSpPr>
-      <p:sp>
-        <p:nvSpPr>
-          <p:cNvPr id="2" name="Slide Image Placeholder 1"/>
-          <p:cNvSpPr>
-            <a:spLocks noGrp="1"/>
-          </p:cNvSpPr>
-          <p:nvPr>
-            <p:ph type="sldImg" idx="2"/>
-          </p:nvPr>
-        </p:nvSpPr>
-        <p:spPr/>
-      </p:sp>
-      <p:sp>
-        <p:nvSpPr>
-          <p:cNvPr id="3" name="Notes Placeholder 2"/>
-          <p:cNvSpPr>
-            <a:spLocks noGrp="1"/>
-          </p:cNvSpPr>
-          <p:nvPr>
-            <p:ph type="body" idx="3" sz="quarter"/>
-          </p:nvPr>
-        </p:nvSpPr>
-        <p:spPr/>
-        <p:txBody>
-          <a:bodyPr/>
-          <a:lstStyle/>
-          <a:p/>
-        </p:txBody>
-      </p:sp>
-      <p:sp>
-        <p:nvSpPr>
-          <p:cNvPr id="4" name="Slide Number Placeholder 3"/>
-          <p:cNvSpPr>
-            <a:spLocks noGrp="1"/>
-          </p:cNvSpPr>
-          <p:nvPr>
-            <p:ph type="sldNum" idx="5" sz="quarter"/>
-          </p:nvPr>
-        </p:nvSpPr>
-        <p:spPr/>
-      </p:sp>
-    </p:spTree>
-  </p:cSld>
-  <p:clrMapOvr>
-    <a:masterClrMapping/>
-  </p:clrMapOvr>
-</p:notes>
-</file>
-
-<file path=ppt/notesSlides/notesSlide9.xml><?xml version="1.0" encoding="utf-8"?>
-<p:notes xmlns:a="http://schemas.openxmlformats.org/drawingml/2006/main" xmlns:p="http://schemas.openxmlformats.org/presentationml/2006/main" xmlns:r="http://schemas.openxmlformats.org/officeDocument/2006/relationships">
-  <p:cSld>
-    <p:spTree>
-      <p:nvGrpSpPr>
-        <p:cNvPr id="1" name=""/>
-        <p:cNvGrpSpPr/>
-        <p:nvPr/>
-      </p:nvGrpSpPr>
-      <p:grpSpPr>
-        <a:xfrm>
-          <a:off x="0" y="0"/>
-          <a:ext cx="0" cy="0"/>
-          <a:chOff x="0" y="0"/>
-          <a:chExt cx="0" cy="0"/>
-        </a:xfrm>
-      </p:grpSpPr>
-      <p:sp>
-        <p:nvSpPr>
-          <p:cNvPr id="2" name="Slide Image Placeholder 1"/>
-          <p:cNvSpPr>
-            <a:spLocks noGrp="1"/>
-          </p:cNvSpPr>
-          <p:nvPr>
-            <p:ph type="sldImg" idx="2"/>
-          </p:nvPr>
-        </p:nvSpPr>
-        <p:spPr/>
-      </p:sp>
-      <p:sp>
-        <p:nvSpPr>
-          <p:cNvPr id="3" name="Notes Placeholder 2"/>
-          <p:cNvSpPr>
-            <a:spLocks noGrp="1"/>
-          </p:cNvSpPr>
-          <p:nvPr>
-            <p:ph type="body" idx="3" sz="quarter"/>
-          </p:nvPr>
-        </p:nvSpPr>
-        <p:spPr/>
-        <p:txBody>
-          <a:bodyPr/>
-          <a:lstStyle/>
-          <a:p/>
-        </p:txBody>
-      </p:sp>
-      <p:sp>
-        <p:nvSpPr>
-          <p:cNvPr id="4" name="Slide Number Placeholder 3"/>
-          <p:cNvSpPr>
-            <a:spLocks noGrp="1"/>
-          </p:cNvSpPr>
-          <p:nvPr>
-            <p:ph type="sldNum" idx="5" sz="quarter"/>
-          </p:nvPr>
-        </p:nvSpPr>
-        <p:spPr/>
-      </p:sp>
-    </p:spTree>
-  </p:cSld>
-  <p:clrMapOvr>
-    <a:masterClrMapping/>
-  </p:clrMapOvr>
-</p:notes>
-</file>
-
 <file path=ppt/slideLayouts/slideLayout1.xml><?xml version="1.0" encoding="utf-8"?>
 <p:sldLayout xmlns:a="http://schemas.openxmlformats.org/drawingml/2006/main" xmlns:r="http://schemas.openxmlformats.org/officeDocument/2006/relationships" xmlns:p="http://schemas.openxmlformats.org/presentationml/2006/main" type="title" preserve="1">
   <p:cSld name="Title Slide">
@@ -25884,7 +23554,7 @@
         </p:nvSpPr>
         <p:spPr>
           <a:xfrm>
-            <a:off x="1280160" y="1600200"/>
+            <a:off x="1280160" y="3840480"/>
             <a:ext cx="1051560" cy="1051560"/>
           </a:xfrm>
           <a:prstGeom prst="ellipse">
@@ -25927,7 +23597,7 @@
         </p:nvSpPr>
         <p:spPr>
           <a:xfrm>
-            <a:off x="1280160" y="1783080"/>
+            <a:off x="1280160" y="4023360"/>
             <a:ext cx="1051560" cy="640080"/>
           </a:xfrm>
           <a:prstGeom prst="rect">
@@ -25962,7 +23632,7 @@
         </p:nvSpPr>
         <p:spPr>
           <a:xfrm>
-            <a:off x="548640" y="2788920"/>
+            <a:off x="548640" y="5029200"/>
             <a:ext cx="2514600" cy="457200"/>
           </a:xfrm>
           <a:prstGeom prst="rect">
@@ -26040,7 +23710,7 @@
         </p:nvSpPr>
         <p:spPr>
           <a:xfrm>
-            <a:off x="4206240" y="1600200"/>
+            <a:off x="4206240" y="3840480"/>
             <a:ext cx="1051560" cy="1051560"/>
           </a:xfrm>
           <a:prstGeom prst="ellipse">
@@ -26083,7 +23753,7 @@
         </p:nvSpPr>
         <p:spPr>
           <a:xfrm>
-            <a:off x="4206240" y="1783080"/>
+            <a:off x="4206240" y="4023360"/>
             <a:ext cx="1051560" cy="640080"/>
           </a:xfrm>
           <a:prstGeom prst="rect">
@@ -26118,7 +23788,7 @@
         </p:nvSpPr>
         <p:spPr>
           <a:xfrm>
-            <a:off x="3474720" y="2788920"/>
+            <a:off x="3474720" y="5029200"/>
             <a:ext cx="2514600" cy="457200"/>
           </a:xfrm>
           <a:prstGeom prst="rect">
@@ -26196,7 +23866,7 @@
         </p:nvSpPr>
         <p:spPr>
           <a:xfrm>
-            <a:off x="7132320" y="1600200"/>
+            <a:off x="7132320" y="3840480"/>
             <a:ext cx="1051560" cy="1051560"/>
           </a:xfrm>
           <a:prstGeom prst="ellipse">
@@ -26239,7 +23909,7 @@
         </p:nvSpPr>
         <p:spPr>
           <a:xfrm>
-            <a:off x="7132320" y="1783080"/>
+            <a:off x="7132320" y="4023360"/>
             <a:ext cx="1051560" cy="640080"/>
           </a:xfrm>
           <a:prstGeom prst="rect">
@@ -26274,7 +23944,7 @@
         </p:nvSpPr>
         <p:spPr>
           <a:xfrm>
-            <a:off x="6400800" y="2788920"/>
+            <a:off x="6400800" y="5029200"/>
             <a:ext cx="2514600" cy="457200"/>
           </a:xfrm>
           <a:prstGeom prst="rect">
@@ -26352,7 +24022,7 @@
         </p:nvSpPr>
         <p:spPr>
           <a:xfrm>
-            <a:off x="10058400" y="1600200"/>
+            <a:off x="10058400" y="3840480"/>
             <a:ext cx="1051560" cy="1051560"/>
           </a:xfrm>
           <a:prstGeom prst="ellipse">
@@ -26395,7 +24065,7 @@
         </p:nvSpPr>
         <p:spPr>
           <a:xfrm>
-            <a:off x="10058400" y="1783080"/>
+            <a:off x="10058400" y="4023360"/>
             <a:ext cx="1051560" cy="640080"/>
           </a:xfrm>
           <a:prstGeom prst="rect">
@@ -26430,7 +24100,7 @@
         </p:nvSpPr>
         <p:spPr>
           <a:xfrm>
-            <a:off x="9326880" y="2788920"/>
+            <a:off x="9326880" y="5029200"/>
             <a:ext cx="2514600" cy="457200"/>
           </a:xfrm>
           <a:prstGeom prst="rect">
@@ -30635,22 +28305,22 @@
         <p:spPr>
           <a:xfrm>
             <a:off x="502920" y="1600200"/>
-            <a:ext cx="3429000" cy="411480"/>
-          </a:xfrm>
-          <a:prstGeom prst="rect">
-            <a:avLst/>
-          </a:prstGeom>
-          <a:noFill/>
-        </p:spPr>
-        <p:txBody>
-          <a:bodyPr wrap="square">
-            <a:spAutoFit/>
-          </a:bodyPr>
-          <a:lstStyle/>
-          <a:p>
-            <a:pPr algn="ctr"/>
-            <a:r>
-              <a:rPr sz="1800" b="1">
+            <a:ext cx="3429000" cy="502920"/>
+          </a:xfrm>
+          <a:prstGeom prst="rect">
+            <a:avLst/>
+          </a:prstGeom>
+          <a:noFill/>
+        </p:spPr>
+        <p:txBody>
+          <a:bodyPr wrap="square">
+            <a:spAutoFit/>
+          </a:bodyPr>
+          <a:lstStyle/>
+          <a:p>
+            <a:pPr algn="ctr"/>
+            <a:r>
+              <a:rPr sz="1700" b="1">
                 <a:solidFill>
                   <a:srgbClr val="0A2A6E"/>
                 </a:solidFill>
@@ -30669,8 +28339,8 @@
         </p:nvSpPr>
         <p:spPr>
           <a:xfrm>
-            <a:off x="502920" y="2148840"/>
-            <a:ext cx="3429000" cy="411480"/>
+            <a:off x="502920" y="2194560"/>
+            <a:ext cx="3429000" cy="457200"/>
           </a:xfrm>
           <a:prstGeom prst="rect">
             <a:avLst/>
@@ -30704,7 +28374,7 @@
         </p:nvSpPr>
         <p:spPr>
           <a:xfrm>
-            <a:off x="502920" y="2697480"/>
+            <a:off x="502920" y="2788920"/>
             <a:ext cx="3429000" cy="411480"/>
           </a:xfrm>
           <a:prstGeom prst="rect">
@@ -30783,22 +28453,22 @@
         <p:spPr>
           <a:xfrm>
             <a:off x="4434840" y="1600200"/>
-            <a:ext cx="3429000" cy="411480"/>
-          </a:xfrm>
-          <a:prstGeom prst="rect">
-            <a:avLst/>
-          </a:prstGeom>
-          <a:noFill/>
-        </p:spPr>
-        <p:txBody>
-          <a:bodyPr wrap="square">
-            <a:spAutoFit/>
-          </a:bodyPr>
-          <a:lstStyle/>
-          <a:p>
-            <a:pPr algn="ctr"/>
-            <a:r>
-              <a:rPr sz="1800" b="1">
+            <a:ext cx="3429000" cy="502920"/>
+          </a:xfrm>
+          <a:prstGeom prst="rect">
+            <a:avLst/>
+          </a:prstGeom>
+          <a:noFill/>
+        </p:spPr>
+        <p:txBody>
+          <a:bodyPr wrap="square">
+            <a:spAutoFit/>
+          </a:bodyPr>
+          <a:lstStyle/>
+          <a:p>
+            <a:pPr algn="ctr"/>
+            <a:r>
+              <a:rPr sz="1700" b="1">
                 <a:solidFill>
                   <a:srgbClr val="0A2A6E"/>
                 </a:solidFill>
@@ -30817,8 +28487,8 @@
         </p:nvSpPr>
         <p:spPr>
           <a:xfrm>
-            <a:off x="4434840" y="2148840"/>
-            <a:ext cx="3429000" cy="411480"/>
+            <a:off x="4434840" y="2194560"/>
+            <a:ext cx="3429000" cy="457200"/>
           </a:xfrm>
           <a:prstGeom prst="rect">
             <a:avLst/>
@@ -30852,7 +28522,7 @@
         </p:nvSpPr>
         <p:spPr>
           <a:xfrm>
-            <a:off x="4434840" y="2697480"/>
+            <a:off x="4434840" y="2788920"/>
             <a:ext cx="3429000" cy="411480"/>
           </a:xfrm>
           <a:prstGeom prst="rect">
@@ -30931,22 +28601,22 @@
         <p:spPr>
           <a:xfrm>
             <a:off x="8366760" y="1600200"/>
-            <a:ext cx="3429000" cy="411480"/>
-          </a:xfrm>
-          <a:prstGeom prst="rect">
-            <a:avLst/>
-          </a:prstGeom>
-          <a:noFill/>
-        </p:spPr>
-        <p:txBody>
-          <a:bodyPr wrap="square">
-            <a:spAutoFit/>
-          </a:bodyPr>
-          <a:lstStyle/>
-          <a:p>
-            <a:pPr algn="ctr"/>
-            <a:r>
-              <a:rPr sz="1800" b="1">
+            <a:ext cx="3429000" cy="502920"/>
+          </a:xfrm>
+          <a:prstGeom prst="rect">
+            <a:avLst/>
+          </a:prstGeom>
+          <a:noFill/>
+        </p:spPr>
+        <p:txBody>
+          <a:bodyPr wrap="square">
+            <a:spAutoFit/>
+          </a:bodyPr>
+          <a:lstStyle/>
+          <a:p>
+            <a:pPr algn="ctr"/>
+            <a:r>
+              <a:rPr sz="1700" b="1">
                 <a:solidFill>
                   <a:srgbClr val="0A2A6E"/>
                 </a:solidFill>
@@ -30965,8 +28635,8 @@
         </p:nvSpPr>
         <p:spPr>
           <a:xfrm>
-            <a:off x="8366760" y="2148840"/>
-            <a:ext cx="3429000" cy="411480"/>
+            <a:off x="8366760" y="2194560"/>
+            <a:ext cx="3429000" cy="457200"/>
           </a:xfrm>
           <a:prstGeom prst="rect">
             <a:avLst/>
@@ -31000,7 +28670,7 @@
         </p:nvSpPr>
         <p:spPr>
           <a:xfrm>
-            <a:off x="8366760" y="2697480"/>
+            <a:off x="8366760" y="2788920"/>
             <a:ext cx="3429000" cy="411480"/>
           </a:xfrm>
           <a:prstGeom prst="rect">
@@ -31078,23 +28748,23 @@
         </p:nvSpPr>
         <p:spPr>
           <a:xfrm>
-            <a:off x="502920" y="1600200"/>
-            <a:ext cx="3429000" cy="411480"/>
-          </a:xfrm>
-          <a:prstGeom prst="rect">
-            <a:avLst/>
-          </a:prstGeom>
-          <a:noFill/>
-        </p:spPr>
-        <p:txBody>
-          <a:bodyPr wrap="square">
-            <a:spAutoFit/>
-          </a:bodyPr>
-          <a:lstStyle/>
-          <a:p>
-            <a:pPr algn="ctr"/>
-            <a:r>
-              <a:rPr sz="1800" b="1">
+            <a:off x="502920" y="3886200"/>
+            <a:ext cx="3429000" cy="502920"/>
+          </a:xfrm>
+          <a:prstGeom prst="rect">
+            <a:avLst/>
+          </a:prstGeom>
+          <a:noFill/>
+        </p:spPr>
+        <p:txBody>
+          <a:bodyPr wrap="square">
+            <a:spAutoFit/>
+          </a:bodyPr>
+          <a:lstStyle/>
+          <a:p>
+            <a:pPr algn="ctr"/>
+            <a:r>
+              <a:rPr sz="1700" b="1">
                 <a:solidFill>
                   <a:srgbClr val="0A2A6E"/>
                 </a:solidFill>
@@ -31113,8 +28783,8 @@
         </p:nvSpPr>
         <p:spPr>
           <a:xfrm>
-            <a:off x="502920" y="2148840"/>
-            <a:ext cx="3429000" cy="411480"/>
+            <a:off x="502920" y="4480560"/>
+            <a:ext cx="3429000" cy="457200"/>
           </a:xfrm>
           <a:prstGeom prst="rect">
             <a:avLst/>
@@ -31148,7 +28818,7 @@
         </p:nvSpPr>
         <p:spPr>
           <a:xfrm>
-            <a:off x="502920" y="2697480"/>
+            <a:off x="502920" y="5074920"/>
             <a:ext cx="3429000" cy="411480"/>
           </a:xfrm>
           <a:prstGeom prst="rect">
@@ -31226,23 +28896,23 @@
         </p:nvSpPr>
         <p:spPr>
           <a:xfrm>
-            <a:off x="4434840" y="1600200"/>
-            <a:ext cx="3429000" cy="411480"/>
-          </a:xfrm>
-          <a:prstGeom prst="rect">
-            <a:avLst/>
-          </a:prstGeom>
-          <a:noFill/>
-        </p:spPr>
-        <p:txBody>
-          <a:bodyPr wrap="square">
-            <a:spAutoFit/>
-          </a:bodyPr>
-          <a:lstStyle/>
-          <a:p>
-            <a:pPr algn="ctr"/>
-            <a:r>
-              <a:rPr sz="1800" b="1">
+            <a:off x="4434840" y="3886200"/>
+            <a:ext cx="3429000" cy="502920"/>
+          </a:xfrm>
+          <a:prstGeom prst="rect">
+            <a:avLst/>
+          </a:prstGeom>
+          <a:noFill/>
+        </p:spPr>
+        <p:txBody>
+          <a:bodyPr wrap="square">
+            <a:spAutoFit/>
+          </a:bodyPr>
+          <a:lstStyle/>
+          <a:p>
+            <a:pPr algn="ctr"/>
+            <a:r>
+              <a:rPr sz="1700" b="1">
                 <a:solidFill>
                   <a:srgbClr val="0A2A6E"/>
                 </a:solidFill>
@@ -31261,8 +28931,8 @@
         </p:nvSpPr>
         <p:spPr>
           <a:xfrm>
-            <a:off x="4434840" y="2148840"/>
-            <a:ext cx="3429000" cy="411480"/>
+            <a:off x="4434840" y="4480560"/>
+            <a:ext cx="3429000" cy="457200"/>
           </a:xfrm>
           <a:prstGeom prst="rect">
             <a:avLst/>
@@ -31296,7 +28966,7 @@
         </p:nvSpPr>
         <p:spPr>
           <a:xfrm>
-            <a:off x="4434840" y="2697480"/>
+            <a:off x="4434840" y="5074920"/>
             <a:ext cx="3429000" cy="411480"/>
           </a:xfrm>
           <a:prstGeom prst="rect">
@@ -31374,23 +29044,23 @@
         </p:nvSpPr>
         <p:spPr>
           <a:xfrm>
-            <a:off x="8366760" y="1600200"/>
-            <a:ext cx="3429000" cy="411480"/>
-          </a:xfrm>
-          <a:prstGeom prst="rect">
-            <a:avLst/>
-          </a:prstGeom>
-          <a:noFill/>
-        </p:spPr>
-        <p:txBody>
-          <a:bodyPr wrap="square">
-            <a:spAutoFit/>
-          </a:bodyPr>
-          <a:lstStyle/>
-          <a:p>
-            <a:pPr algn="ctr"/>
-            <a:r>
-              <a:rPr sz="1800" b="1">
+            <a:off x="8366760" y="3886200"/>
+            <a:ext cx="3429000" cy="502920"/>
+          </a:xfrm>
+          <a:prstGeom prst="rect">
+            <a:avLst/>
+          </a:prstGeom>
+          <a:noFill/>
+        </p:spPr>
+        <p:txBody>
+          <a:bodyPr wrap="square">
+            <a:spAutoFit/>
+          </a:bodyPr>
+          <a:lstStyle/>
+          <a:p>
+            <a:pPr algn="ctr"/>
+            <a:r>
+              <a:rPr sz="1700" b="1">
                 <a:solidFill>
                   <a:srgbClr val="0A2A6E"/>
                 </a:solidFill>
@@ -31409,8 +29079,8 @@
         </p:nvSpPr>
         <p:spPr>
           <a:xfrm>
-            <a:off x="8366760" y="2148840"/>
-            <a:ext cx="3429000" cy="411480"/>
+            <a:off x="8366760" y="4480560"/>
+            <a:ext cx="3429000" cy="457200"/>
           </a:xfrm>
           <a:prstGeom prst="rect">
             <a:avLst/>
@@ -31444,7 +29114,7 @@
         </p:nvSpPr>
         <p:spPr>
           <a:xfrm>
-            <a:off x="8366760" y="2697480"/>
+            <a:off x="8366760" y="5074920"/>
             <a:ext cx="3429000" cy="411480"/>
           </a:xfrm>
           <a:prstGeom prst="rect">
@@ -33359,7 +31029,7 @@
         <p:spPr>
           <a:xfrm>
             <a:off x="548640" y="2697480"/>
-            <a:ext cx="3337560" cy="457200"/>
+            <a:ext cx="3337560" cy="502920"/>
           </a:xfrm>
           <a:prstGeom prst="rect">
             <a:avLst/>
@@ -33515,7 +31185,7 @@
         <p:spPr>
           <a:xfrm>
             <a:off x="4434840" y="2697480"/>
-            <a:ext cx="3337560" cy="457200"/>
+            <a:ext cx="3337560" cy="502920"/>
           </a:xfrm>
           <a:prstGeom prst="rect">
             <a:avLst/>
@@ -33671,7 +31341,7 @@
         <p:spPr>
           <a:xfrm>
             <a:off x="8321040" y="2697480"/>
-            <a:ext cx="3337560" cy="457200"/>
+            <a:ext cx="3337560" cy="502920"/>
           </a:xfrm>
           <a:prstGeom prst="rect">
             <a:avLst/>
@@ -33748,7 +31418,7 @@
         </p:nvSpPr>
         <p:spPr>
           <a:xfrm>
-            <a:off x="1783080" y="1600200"/>
+            <a:off x="1783080" y="3794760"/>
             <a:ext cx="868680" cy="868680"/>
           </a:xfrm>
           <a:prstGeom prst="ellipse">
@@ -33791,7 +31461,7 @@
         </p:nvSpPr>
         <p:spPr>
           <a:xfrm>
-            <a:off x="1783080" y="1783080"/>
+            <a:off x="1783080" y="3977640"/>
             <a:ext cx="868680" cy="502920"/>
           </a:xfrm>
           <a:prstGeom prst="rect">
@@ -33826,8 +31496,8 @@
         </p:nvSpPr>
         <p:spPr>
           <a:xfrm>
-            <a:off x="548640" y="2697480"/>
-            <a:ext cx="3337560" cy="457200"/>
+            <a:off x="548640" y="4892040"/>
+            <a:ext cx="3337560" cy="502920"/>
           </a:xfrm>
           <a:prstGeom prst="rect">
             <a:avLst/>
@@ -33904,7 +31574,7 @@
         </p:nvSpPr>
         <p:spPr>
           <a:xfrm>
-            <a:off x="5669280" y="1600200"/>
+            <a:off x="5669280" y="3794760"/>
             <a:ext cx="868680" cy="868680"/>
           </a:xfrm>
           <a:prstGeom prst="ellipse">
@@ -33947,7 +31617,7 @@
         </p:nvSpPr>
         <p:spPr>
           <a:xfrm>
-            <a:off x="5669280" y="1783080"/>
+            <a:off x="5669280" y="3977640"/>
             <a:ext cx="868680" cy="502920"/>
           </a:xfrm>
           <a:prstGeom prst="rect">
@@ -33982,8 +31652,8 @@
         </p:nvSpPr>
         <p:spPr>
           <a:xfrm>
-            <a:off x="4434840" y="2697480"/>
-            <a:ext cx="3337560" cy="457200"/>
+            <a:off x="4434840" y="4892040"/>
+            <a:ext cx="3337560" cy="502920"/>
           </a:xfrm>
           <a:prstGeom prst="rect">
             <a:avLst/>
@@ -34060,7 +31730,7 @@
         </p:nvSpPr>
         <p:spPr>
           <a:xfrm>
-            <a:off x="9555480" y="1600200"/>
+            <a:off x="9555480" y="3794760"/>
             <a:ext cx="868680" cy="868680"/>
           </a:xfrm>
           <a:prstGeom prst="ellipse">
@@ -34103,7 +31773,7 @@
         </p:nvSpPr>
         <p:spPr>
           <a:xfrm>
-            <a:off x="9555480" y="1783080"/>
+            <a:off x="9555480" y="3977640"/>
             <a:ext cx="868680" cy="502920"/>
           </a:xfrm>
           <a:prstGeom prst="rect">
@@ -34138,8 +31808,8 @@
         </p:nvSpPr>
         <p:spPr>
           <a:xfrm>
-            <a:off x="8321040" y="2697480"/>
-            <a:ext cx="3337560" cy="457200"/>
+            <a:off x="8321040" y="4892040"/>
+            <a:ext cx="3337560" cy="502920"/>
           </a:xfrm>
           <a:prstGeom prst="rect">
             <a:avLst/>
@@ -34572,324 +32242,4 @@
   </a:objectDefaults>
   <a:extraClrSchemeLst/>
 </a:theme>
-</file>
-
-<file path=ppt/theme/theme2.xml><?xml version="1.0" encoding="utf-8"?>
-<a:theme xmlns:a="http://schemas.openxmlformats.org/drawingml/2006/main" name="Office Theme">
-  <a:themeElements>
-    <a:clrScheme name="Office">
-      <a:dk1>
-        <a:sysClr val="windowText" lastClr="000000"/>
-      </a:dk1>
-      <a:lt1>
-        <a:sysClr val="window" lastClr="FFFFFF"/>
-      </a:lt1>
-      <a:dk2>
-        <a:srgbClr val="1F497D"/>
-      </a:dk2>
-      <a:lt2>
-        <a:srgbClr val="EEECE1"/>
-      </a:lt2>
-      <a:accent1>
-        <a:srgbClr val="4F81BD"/>
-      </a:accent1>
-      <a:accent2>
-        <a:srgbClr val="C0504D"/>
-      </a:accent2>
-      <a:accent3>
-        <a:srgbClr val="9BBB59"/>
-      </a:accent3>
-      <a:accent4>
-        <a:srgbClr val="8064A2"/>
-      </a:accent4>
-      <a:accent5>
-        <a:srgbClr val="4BACC6"/>
-      </a:accent5>
-      <a:accent6>
-        <a:srgbClr val="F79646"/>
-      </a:accent6>
-      <a:hlink>
-        <a:srgbClr val="0000FF"/>
-      </a:hlink>
-      <a:folHlink>
-        <a:srgbClr val="800080"/>
-      </a:folHlink>
-    </a:clrScheme>
-    <a:fontScheme name="Office">
-      <a:majorFont>
-        <a:latin typeface="Calibri"/>
-        <a:ea typeface=""/>
-        <a:cs typeface=""/>
-        <a:font script="Jpan" typeface="ＭＳ Ｐゴシック"/>
-        <a:font script="Hang" typeface="맑은 고딕"/>
-        <a:font script="Hans" typeface="宋体"/>
-        <a:font script="Hant" typeface="新細明體"/>
-        <a:font script="Arab" typeface="Times New Roman"/>
-        <a:font script="Hebr" typeface="Times New Roman"/>
-        <a:font script="Thai" typeface="Angsana New"/>
-        <a:font script="Ethi" typeface="Nyala"/>
-        <a:font script="Beng" typeface="Vrinda"/>
-        <a:font script="Gujr" typeface="Shruti"/>
-        <a:font script="Khmr" typeface="MoolBoran"/>
-        <a:font script="Knda" typeface="Tunga"/>
-        <a:font script="Guru" typeface="Raavi"/>
-        <a:font script="Cans" typeface="Euphemia"/>
-        <a:font script="Cher" typeface="Plantagenet Cherokee"/>
-        <a:font script="Yiii" typeface="Microsoft Yi Baiti"/>
-        <a:font script="Tibt" typeface="Microsoft Himalaya"/>
-        <a:font script="Thaa" typeface="MV Boli"/>
-        <a:font script="Deva" typeface="Mangal"/>
-        <a:font script="Telu" typeface="Gautami"/>
-        <a:font script="Taml" typeface="Latha"/>
-        <a:font script="Syrc" typeface="Estrangelo Edessa"/>
-        <a:font script="Orya" typeface="Kalinga"/>
-        <a:font script="Mlym" typeface="Kartika"/>
-        <a:font script="Laoo" typeface="DokChampa"/>
-        <a:font script="Sinh" typeface="Iskoola Pota"/>
-        <a:font script="Mong" typeface="Mongolian Baiti"/>
-        <a:font script="Viet" typeface="Times New Roman"/>
-        <a:font script="Uigh" typeface="Microsoft Uighur"/>
-        <a:font script="Geor" typeface="Sylfaen"/>
-      </a:majorFont>
-      <a:minorFont>
-        <a:latin typeface="Calibri"/>
-        <a:ea typeface=""/>
-        <a:cs typeface=""/>
-        <a:font script="Jpan" typeface="ＭＳ Ｐゴシック"/>
-        <a:font script="Hang" typeface="맑은 고딕"/>
-        <a:font script="Hans" typeface="宋体"/>
-        <a:font script="Hant" typeface="新細明體"/>
-        <a:font script="Arab" typeface="Arial"/>
-        <a:font script="Hebr" typeface="Arial"/>
-        <a:font script="Thai" typeface="Cordia New"/>
-        <a:font script="Ethi" typeface="Nyala"/>
-        <a:font script="Beng" typeface="Vrinda"/>
-        <a:font script="Gujr" typeface="Shruti"/>
-        <a:font script="Khmr" typeface="DaunPenh"/>
-        <a:font script="Knda" typeface="Tunga"/>
-        <a:font script="Guru" typeface="Raavi"/>
-        <a:font script="Cans" typeface="Euphemia"/>
-        <a:font script="Cher" typeface="Plantagenet Cherokee"/>
-        <a:font script="Yiii" typeface="Microsoft Yi Baiti"/>
-        <a:font script="Tibt" typeface="Microsoft Himalaya"/>
-        <a:font script="Thaa" typeface="MV Boli"/>
-        <a:font script="Deva" typeface="Mangal"/>
-        <a:font script="Telu" typeface="Gautami"/>
-        <a:font script="Taml" typeface="Latha"/>
-        <a:font script="Syrc" typeface="Estrangelo Edessa"/>
-        <a:font script="Orya" typeface="Kalinga"/>
-        <a:font script="Mlym" typeface="Kartika"/>
-        <a:font script="Laoo" typeface="DokChampa"/>
-        <a:font script="Sinh" typeface="Iskoola Pota"/>
-        <a:font script="Mong" typeface="Mongolian Baiti"/>
-        <a:font script="Viet" typeface="Arial"/>
-        <a:font script="Uigh" typeface="Microsoft Uighur"/>
-        <a:font script="Geor" typeface="Sylfaen"/>
-      </a:minorFont>
-    </a:fontScheme>
-    <a:fmtScheme name="Office">
-      <a:fillStyleLst>
-        <a:solidFill>
-          <a:schemeClr val="phClr"/>
-        </a:solidFill>
-        <a:gradFill rotWithShape="1">
-          <a:gsLst>
-            <a:gs pos="0">
-              <a:schemeClr val="phClr">
-                <a:tint val="50000"/>
-                <a:satMod val="300000"/>
-              </a:schemeClr>
-            </a:gs>
-            <a:gs pos="35000">
-              <a:schemeClr val="phClr">
-                <a:tint val="37000"/>
-                <a:satMod val="300000"/>
-              </a:schemeClr>
-            </a:gs>
-            <a:gs pos="100000">
-              <a:schemeClr val="phClr">
-                <a:tint val="15000"/>
-                <a:satMod val="350000"/>
-              </a:schemeClr>
-            </a:gs>
-          </a:gsLst>
-          <a:lin ang="16200000" scaled="1"/>
-        </a:gradFill>
-        <a:gradFill rotWithShape="1">
-          <a:gsLst>
-            <a:gs pos="0">
-              <a:schemeClr val="phClr">
-                <a:tint val="100000"/>
-                <a:shade val="100000"/>
-                <a:satMod val="130000"/>
-              </a:schemeClr>
-            </a:gs>
-            <a:gs pos="100000">
-              <a:schemeClr val="phClr">
-                <a:tint val="50000"/>
-                <a:shade val="100000"/>
-                <a:satMod val="350000"/>
-              </a:schemeClr>
-            </a:gs>
-          </a:gsLst>
-          <a:lin ang="16200000" scaled="0"/>
-        </a:gradFill>
-      </a:fillStyleLst>
-      <a:lnStyleLst>
-        <a:ln w="9525" cap="flat" cmpd="sng" algn="ctr">
-          <a:solidFill>
-            <a:schemeClr val="phClr">
-              <a:shade val="95000"/>
-              <a:satMod val="105000"/>
-            </a:schemeClr>
-          </a:solidFill>
-          <a:prstDash val="solid"/>
-        </a:ln>
-        <a:ln w="25400" cap="flat" cmpd="sng" algn="ctr">
-          <a:solidFill>
-            <a:schemeClr val="phClr"/>
-          </a:solidFill>
-          <a:prstDash val="solid"/>
-        </a:ln>
-        <a:ln w="38100" cap="flat" cmpd="sng" algn="ctr">
-          <a:solidFill>
-            <a:schemeClr val="phClr"/>
-          </a:solidFill>
-          <a:prstDash val="solid"/>
-        </a:ln>
-      </a:lnStyleLst>
-      <a:effectStyleLst>
-        <a:effectStyle>
-          <a:effectLst>
-            <a:outerShdw blurRad="40000" dist="20000" dir="5400000" rotWithShape="0">
-              <a:srgbClr val="000000">
-                <a:alpha val="38000"/>
-              </a:srgbClr>
-            </a:outerShdw>
-          </a:effectLst>
-        </a:effectStyle>
-        <a:effectStyle>
-          <a:effectLst>
-            <a:outerShdw blurRad="40000" dist="23000" dir="5400000" rotWithShape="0">
-              <a:srgbClr val="000000">
-                <a:alpha val="35000"/>
-              </a:srgbClr>
-            </a:outerShdw>
-          </a:effectLst>
-        </a:effectStyle>
-        <a:effectStyle>
-          <a:effectLst>
-            <a:outerShdw blurRad="40000" dist="23000" dir="5400000" rotWithShape="0">
-              <a:srgbClr val="000000">
-                <a:alpha val="35000"/>
-              </a:srgbClr>
-            </a:outerShdw>
-          </a:effectLst>
-          <a:scene3d>
-            <a:camera prst="orthographicFront">
-              <a:rot lat="0" lon="0" rev="0"/>
-            </a:camera>
-            <a:lightRig rig="threePt" dir="t">
-              <a:rot lat="0" lon="0" rev="1200000"/>
-            </a:lightRig>
-          </a:scene3d>
-          <a:sp3d>
-            <a:bevelT w="63500" h="25400"/>
-          </a:sp3d>
-        </a:effectStyle>
-      </a:effectStyleLst>
-      <a:bgFillStyleLst>
-        <a:solidFill>
-          <a:schemeClr val="phClr"/>
-        </a:solidFill>
-        <a:gradFill rotWithShape="1">
-          <a:gsLst>
-            <a:gs pos="0">
-              <a:schemeClr val="phClr">
-                <a:tint val="40000"/>
-                <a:satMod val="350000"/>
-              </a:schemeClr>
-            </a:gs>
-            <a:gs pos="40000">
-              <a:schemeClr val="phClr">
-                <a:tint val="45000"/>
-                <a:shade val="99000"/>
-                <a:satMod val="350000"/>
-              </a:schemeClr>
-            </a:gs>
-            <a:gs pos="100000">
-              <a:schemeClr val="phClr">
-                <a:shade val="20000"/>
-                <a:satMod val="255000"/>
-              </a:schemeClr>
-            </a:gs>
-          </a:gsLst>
-          <a:path path="circle">
-            <a:fillToRect l="50000" t="-80000" r="50000" b="180000"/>
-          </a:path>
-        </a:gradFill>
-        <a:gradFill rotWithShape="1">
-          <a:gsLst>
-            <a:gs pos="0">
-              <a:schemeClr val="phClr">
-                <a:tint val="80000"/>
-                <a:satMod val="300000"/>
-              </a:schemeClr>
-            </a:gs>
-            <a:gs pos="100000">
-              <a:schemeClr val="phClr">
-                <a:shade val="30000"/>
-                <a:satMod val="200000"/>
-              </a:schemeClr>
-            </a:gs>
-          </a:gsLst>
-          <a:path path="circle">
-            <a:fillToRect l="50000" t="50000" r="50000" b="50000"/>
-          </a:path>
-        </a:gradFill>
-      </a:bgFillStyleLst>
-    </a:fmtScheme>
-  </a:themeElements>
-  <a:objectDefaults>
-    <a:spDef>
-      <a:spPr/>
-      <a:bodyPr/>
-      <a:lstStyle/>
-      <a:style>
-        <a:lnRef idx="1">
-          <a:schemeClr val="accent1"/>
-        </a:lnRef>
-        <a:fillRef idx="3">
-          <a:schemeClr val="accent1"/>
-        </a:fillRef>
-        <a:effectRef idx="2">
-          <a:schemeClr val="accent1"/>
-        </a:effectRef>
-        <a:fontRef idx="minor">
-          <a:schemeClr val="lt1"/>
-        </a:fontRef>
-      </a:style>
-    </a:spDef>
-    <a:lnDef>
-      <a:spPr/>
-      <a:bodyPr/>
-      <a:lstStyle/>
-      <a:style>
-        <a:lnRef idx="2">
-          <a:schemeClr val="accent1"/>
-        </a:lnRef>
-        <a:fillRef idx="0">
-          <a:schemeClr val="accent1"/>
-        </a:fillRef>
-        <a:effectRef idx="1">
-          <a:schemeClr val="accent1"/>
-        </a:effectRef>
-        <a:fontRef idx="minor">
-          <a:schemeClr val="tx1"/>
-        </a:fontRef>
-      </a:style>
-    </a:lnDef>
-  </a:objectDefaults>
-  <a:extraClrSchemeLst/>
-</a:theme>
 </file>
</xml_diff>